<commit_message>
Correct team member name
</commit_message>
<xml_diff>
--- a/Airport_PageRank_Presentation.pptx
+++ b/Airport_PageRank_Presentation.pptx
@@ -2171,7 +2171,7 @@
                 <a:ea typeface="Calibri" pitchFamily="34" charset="-122"/>
                 <a:cs typeface="Calibri" pitchFamily="34" charset="-120"/>
               </a:rPr>
-              <a:t>Team: Mindeok Seo, Jake Barry, Jeewan Khadka, Yijia Zhang, Alan Tang</a:t>
+              <a:t>Team: Mindeok Seo, Jake Gust, Jeewan Khadka, Yijia Zhang, Alan Tang</a:t>
             </a:r>
             <a:endParaRPr lang="en-US" sz="1050" dirty="0"/>
           </a:p>
@@ -3247,7 +3247,7 @@
                 <a:ea typeface="Calibri" pitchFamily="34" charset="-122"/>
                 <a:cs typeface="Calibri" pitchFamily="34" charset="-120"/>
               </a:rPr>
-              <a:t>Team: Mindeok Seo, Jake Barry, Jeewan Khadka, Yijia Zhang, Alan Tang</a:t>
+              <a:t>Team: Mindeok Seo, Jake Gust, Jeewan Khadka, Yijia Zhang, Alan Tang</a:t>
             </a:r>
             <a:endParaRPr lang="en-US" sz="1150" dirty="0"/>
           </a:p>

</xml_diff>

<commit_message>
Add damping factor sensitivity analysis
Recompute PageRank at d = 0.65, 0.75, 0.85, 0.95 to verify the baseline
ranking is driven by the U.S. route network rather than by the standard
choice d = 0.85. The top four hubs (DEN, ATL, ORD, DFW) are stable
across the range, Spearman rank correlation against the baseline stays
above 0.988, and the top-10 set overlaps in 9 of 10 airports at every
damping value tested.

The notebook gains a new section with the sensitivity computation, a
comparison table, summary statistics, and a line plot. README.md and
DISCUSSION.md are updated with the new methodology, table, figure, and
interpretation. The presentation gains a dedicated sensitivity slide
(slide 7); subsequent slides are renumbered. PRESENTER_NOTES.md
captures slide-by-slide talking points and likely audience questions.
A standalone scripts/sensitivity.py reproduces the numbers and saves
figures/damping-factor-sensitivity.png and outputs/damping_sensitivity.csv.
</commit_message>
<xml_diff>
--- a/Airport_PageRank_Presentation.pptx
+++ b/Airport_PageRank_Presentation.pptx
@@ -16,9 +16,10 @@
     <p:sldId id="264" r:id="rId10"/>
     <p:sldId id="265" r:id="rId11"/>
     <p:sldId id="266" r:id="rId12"/>
+    <p:sldId id="267" r:id="rId13"/>
   </p:sldIdLst>
   <p:notesMasterIdLst>
-    <p:notesMasterId r:id="rId13"/>
+    <p:notesMasterId r:id="rId14"/>
   </p:notesMasterIdLst>
   <p:sldSz cx="12191695" cy="6858000"/>
   <p:notesSz cx="6858000" cy="12191695"/>
@@ -712,6 +713,94 @@
             <a:fld id="{F7021451-1387-4CA6-816F-3879F97B5CBC}" type="slidenum">
               <a:rPr lang="en-US"/>
               <a:t>11</a:t>
+            </a:fld>
+            <a:endParaRPr lang="en-US"/>
+          </a:p>
+        </p:txBody>
+      </p:sp>
+    </p:spTree>
+    <p:extLst>
+      <p:ext uri="{BB962C8B-B14F-4D97-AF65-F5344CB8AC3E}">
+        <p14:creationId xmlns:p14="http://schemas.microsoft.com/office/powerpoint/2010/main" val="1024086991"/>
+      </p:ext>
+    </p:extLst>
+  </p:cSld>
+  <p:clrMapOvr>
+    <a:masterClrMapping/>
+  </p:clrMapOvr>
+</p:notes>
+</file>
+
+<file path=ppt/notesSlides/notesSlide12.xml><?xml version="1.0" encoding="utf-8"?>
+<p:notes xmlns:a="http://schemas.openxmlformats.org/drawingml/2006/main" xmlns:r="http://schemas.openxmlformats.org/officeDocument/2006/relationships" xmlns:p="http://schemas.openxmlformats.org/presentationml/2006/main">
+  <p:cSld>
+    <p:spTree>
+      <p:nvGrpSpPr>
+        <p:cNvPr id="1" name=""/>
+        <p:cNvGrpSpPr/>
+        <p:nvPr/>
+      </p:nvGrpSpPr>
+      <p:grpSpPr>
+        <a:xfrm>
+          <a:off x="0" y="0"/>
+          <a:ext cx="0" cy="0"/>
+          <a:chOff x="0" y="0"/>
+          <a:chExt cx="0" cy="0"/>
+        </a:xfrm>
+      </p:grpSpPr>
+      <p:sp>
+        <p:nvSpPr>
+          <p:cNvPr id="2" name="Slide Image Placeholder 1"/>
+          <p:cNvSpPr>
+            <a:spLocks noGrp="1" noRot="1" noChangeAspect="1"/>
+          </p:cNvSpPr>
+          <p:nvPr>
+            <p:ph type="sldImg"/>
+          </p:nvPr>
+        </p:nvSpPr>
+        <p:spPr/>
+      </p:sp>
+      <p:sp>
+        <p:nvSpPr>
+          <p:cNvPr id="3" name="Notes Placeholder 2"/>
+          <p:cNvSpPr>
+            <a:spLocks noGrp="1"/>
+          </p:cNvSpPr>
+          <p:nvPr>
+            <p:ph type="body" idx="1"/>
+          </p:nvPr>
+        </p:nvSpPr>
+        <p:spPr/>
+        <p:txBody>
+          <a:bodyPr/>
+          <a:lstStyle/>
+          <a:p>
+            <a:r>
+              <a:rPr lang="en-US" dirty="0"/>
+              <a:t/>
+            </a:r>
+            <a:endParaRPr lang="en-US" dirty="0"/>
+          </a:p>
+        </p:txBody>
+      </p:sp>
+      <p:sp>
+        <p:nvSpPr>
+          <p:cNvPr id="4" name="Slide Number Placeholder 3"/>
+          <p:cNvSpPr>
+            <a:spLocks noGrp="1"/>
+          </p:cNvSpPr>
+          <p:nvPr>
+            <p:ph type="sldNum" sz="quarter" idx="10"/>
+          </p:nvPr>
+        </p:nvSpPr>
+        <p:spPr/>
+        <p:txBody>
+          <a:bodyPr/>
+          <a:lstStyle/>
+          <a:p>
+            <a:fld id="{F7021451-1387-4CA6-816F-3879F97B5CBC}" type="slidenum">
+              <a:rPr lang="en-US"/>
+              <a:t>12</a:t>
             </a:fld>
             <a:endParaRPr lang="en-US"/>
           </a:p>
@@ -2458,7 +2547,7 @@
                 <a:ea typeface="Trebuchet MS" pitchFamily="34" charset="-122"/>
                 <a:cs typeface="Trebuchet MS" pitchFamily="34" charset="-120"/>
               </a:rPr>
-              <a:t>Limitations and Extensions</a:t>
+              <a:t>What We Learned</a:t>
             </a:r>
             <a:endParaRPr lang="en-US" sz="2400" dirty="0"/>
           </a:p>
@@ -2497,7 +2586,7 @@
                 <a:ea typeface="Calibri" pitchFamily="34" charset="-122"/>
                 <a:cs typeface="Calibri" pitchFamily="34" charset="-120"/>
               </a:rPr>
-              <a:t>How the project could be strengthened</a:t>
+              <a:t>Centrality and resilience in one model</a:t>
             </a:r>
             <a:endParaRPr lang="en-US" sz="1050" dirty="0"/>
           </a:p>
@@ -2511,12 +2600,121 @@
         </p:nvSpPr>
         <p:spPr>
           <a:xfrm>
-            <a:off x="731520" y="1234440"/>
-            <a:ext cx="5166360" cy="3429000"/>
+            <a:off x="502920" y="1325880"/>
+            <a:ext cx="2788920" cy="2606040"/>
           </a:xfrm>
           <a:prstGeom prst="roundRect">
             <a:avLst>
-              <a:gd name="adj" fmla="val 2133"/>
+              <a:gd name="adj" fmla="val 2807"/>
+            </a:avLst>
+          </a:prstGeom>
+          <a:solidFill>
+            <a:srgbClr val="E9F3F3"/>
+          </a:solidFill>
+          <a:ln w="12700">
+            <a:solidFill>
+              <a:srgbClr val="D4D1CA">
+                <a:alpha val="90000"/>
+              </a:srgbClr>
+            </a:solidFill>
+            <a:prstDash val="solid"/>
+          </a:ln>
+        </p:spPr>
+      </p:sp>
+      <p:sp>
+        <p:nvSpPr>
+          <p:cNvPr id="5" name="Text 3"/>
+          <p:cNvSpPr/>
+          <p:nvPr/>
+        </p:nvSpPr>
+        <p:spPr>
+          <a:xfrm>
+            <a:off x="704088" y="1490472"/>
+            <a:ext cx="2386584" cy="228600"/>
+          </a:xfrm>
+          <a:prstGeom prst="rect">
+            <a:avLst/>
+          </a:prstGeom>
+          <a:noFill/>
+          <a:ln/>
+        </p:spPr>
+        <p:txBody>
+          <a:bodyPr wrap="square" lIns="0" tIns="0" rIns="0" bIns="0" rtlCol="0" anchor="ctr"/>
+          <a:lstStyle/>
+          <a:p>
+            <a:pPr indent="0" marL="0">
+              <a:buNone/>
+            </a:pPr>
+            <a:r>
+              <a:rPr lang="en-US" sz="1400" b="1" dirty="0">
+                <a:solidFill>
+                  <a:srgbClr val="01696F"/>
+                </a:solidFill>
+                <a:latin typeface="Trebuchet MS" pitchFamily="34" charset="0"/>
+                <a:ea typeface="Trebuchet MS" pitchFamily="34" charset="-122"/>
+                <a:cs typeface="Trebuchet MS" pitchFamily="34" charset="-120"/>
+              </a:rPr>
+              <a:t>1. Centrality is recursive</a:t>
+            </a:r>
+            <a:endParaRPr lang="en-US" sz="1400" dirty="0"/>
+          </a:p>
+        </p:txBody>
+      </p:sp>
+      <p:sp>
+        <p:nvSpPr>
+          <p:cNvPr id="6" name="Text 4"/>
+          <p:cNvSpPr/>
+          <p:nvPr/>
+        </p:nvSpPr>
+        <p:spPr>
+          <a:xfrm>
+            <a:off x="704088" y="1828800"/>
+            <a:ext cx="2386584" cy="1920240"/>
+          </a:xfrm>
+          <a:prstGeom prst="rect">
+            <a:avLst/>
+          </a:prstGeom>
+          <a:noFill/>
+          <a:ln/>
+        </p:spPr>
+        <p:txBody>
+          <a:bodyPr wrap="square" lIns="254" tIns="254" rIns="254" bIns="254" rtlCol="0" anchor="t">
+            <a:normAutofit/>
+          </a:bodyPr>
+          <a:lstStyle/>
+          <a:p>
+            <a:pPr indent="0" marL="0">
+              <a:buNone/>
+            </a:pPr>
+            <a:r>
+              <a:rPr lang="en-US" sz="1250" dirty="0">
+                <a:solidFill>
+                  <a:srgbClr val="28251D"/>
+                </a:solidFill>
+                <a:latin typeface="Calibri" pitchFamily="34" charset="0"/>
+                <a:ea typeface="Calibri" pitchFamily="34" charset="-122"/>
+                <a:cs typeface="Calibri" pitchFamily="34" charset="-120"/>
+              </a:rPr>
+              <a:t>An airport is important when it is connected to other important airports, not only when it has many direct routes.</a:t>
+            </a:r>
+            <a:endParaRPr lang="en-US" sz="1250" dirty="0"/>
+          </a:p>
+        </p:txBody>
+      </p:sp>
+      <p:sp>
+        <p:nvSpPr>
+          <p:cNvPr id="7" name="Shape 5"/>
+          <p:cNvSpPr/>
+          <p:nvPr/>
+        </p:nvSpPr>
+        <p:spPr>
+          <a:xfrm>
+            <a:off x="3429000" y="1325880"/>
+            <a:ext cx="2788920" cy="2606040"/>
+          </a:xfrm>
+          <a:prstGeom prst="roundRect">
+            <a:avLst>
+              <a:gd name="adj" fmla="val 2807"/>
             </a:avLst>
           </a:prstGeom>
           <a:solidFill>
@@ -2524,7 +2722,9 @@
           </a:solidFill>
           <a:ln w="12700">
             <a:solidFill>
-              <a:srgbClr val="D4D1CA"/>
+              <a:srgbClr val="D4D1CA">
+                <a:alpha val="90000"/>
+              </a:srgbClr>
             </a:solidFill>
             <a:prstDash val="solid"/>
           </a:ln>
@@ -2532,30 +2732,30 @@
       </p:sp>
       <p:sp>
         <p:nvSpPr>
-          <p:cNvPr id="5" name="Text 3"/>
-          <p:cNvSpPr/>
-          <p:nvPr/>
-        </p:nvSpPr>
-        <p:spPr>
-          <a:xfrm>
-            <a:off x="1051560" y="1554480"/>
-            <a:ext cx="1920240" cy="256032"/>
-          </a:xfrm>
-          <a:prstGeom prst="rect">
-            <a:avLst/>
-          </a:prstGeom>
-          <a:noFill/>
-          <a:ln/>
-        </p:spPr>
-        <p:txBody>
-          <a:bodyPr wrap="square" lIns="0" tIns="0" rIns="0" bIns="0" rtlCol="0" anchor="ctr"/>
-          <a:lstStyle/>
-          <a:p>
-            <a:pPr indent="0" marL="0">
-              <a:buNone/>
-            </a:pPr>
-            <a:r>
-              <a:rPr lang="en-US" sz="1700" b="1" dirty="0">
+          <p:cNvPr id="8" name="Text 6"/>
+          <p:cNvSpPr/>
+          <p:nvPr/>
+        </p:nvSpPr>
+        <p:spPr>
+          <a:xfrm>
+            <a:off x="3630168" y="1490472"/>
+            <a:ext cx="2386584" cy="228600"/>
+          </a:xfrm>
+          <a:prstGeom prst="rect">
+            <a:avLst/>
+          </a:prstGeom>
+          <a:noFill/>
+          <a:ln/>
+        </p:spPr>
+        <p:txBody>
+          <a:bodyPr wrap="square" lIns="0" tIns="0" rIns="0" bIns="0" rtlCol="0" anchor="ctr"/>
+          <a:lstStyle/>
+          <a:p>
+            <a:pPr indent="0" marL="0">
+              <a:buNone/>
+            </a:pPr>
+            <a:r>
+              <a:rPr lang="en-US" sz="1400" b="1" dirty="0">
                 <a:solidFill>
                   <a:srgbClr val="28251D"/>
                 </a:solidFill>
@@ -2563,37 +2763,40 @@
                 <a:ea typeface="Trebuchet MS" pitchFamily="34" charset="-122"/>
                 <a:cs typeface="Trebuchet MS" pitchFamily="34" charset="-120"/>
               </a:rPr>
-              <a:t>Limitations</a:t>
-            </a:r>
-            <a:endParaRPr lang="en-US" sz="1700" dirty="0"/>
-          </a:p>
-        </p:txBody>
-      </p:sp>
-      <p:sp>
-        <p:nvSpPr>
-          <p:cNvPr id="6" name="Text 4"/>
-          <p:cNvSpPr/>
-          <p:nvPr/>
-        </p:nvSpPr>
-        <p:spPr>
-          <a:xfrm>
-            <a:off x="1051560" y="1965960"/>
-            <a:ext cx="4251960" cy="2011680"/>
-          </a:xfrm>
-          <a:prstGeom prst="rect">
-            <a:avLst/>
-          </a:prstGeom>
-          <a:noFill/>
-          <a:ln/>
-        </p:spPr>
-        <p:txBody>
-          <a:bodyPr wrap="square" lIns="635" tIns="635" rIns="635" bIns="635" rtlCol="0" anchor="ctr">
+              <a:t>2. Robust to damping</a:t>
+            </a:r>
+            <a:endParaRPr lang="en-US" sz="1400" dirty="0"/>
+          </a:p>
+        </p:txBody>
+      </p:sp>
+      <p:sp>
+        <p:nvSpPr>
+          <p:cNvPr id="9" name="Text 7"/>
+          <p:cNvSpPr/>
+          <p:nvPr/>
+        </p:nvSpPr>
+        <p:spPr>
+          <a:xfrm>
+            <a:off x="3630168" y="1828800"/>
+            <a:ext cx="2386584" cy="1920240"/>
+          </a:xfrm>
+          <a:prstGeom prst="rect">
+            <a:avLst/>
+          </a:prstGeom>
+          <a:noFill/>
+          <a:ln/>
+        </p:spPr>
+        <p:txBody>
+          <a:bodyPr wrap="square" lIns="254" tIns="254" rIns="254" bIns="254" rtlCol="0" anchor="t">
             <a:normAutofit/>
           </a:bodyPr>
           <a:lstStyle/>
           <a:p>
-            <a:r>
-              <a:rPr lang="en-US" sz="1350" dirty="0">
+            <a:pPr indent="0" marL="0">
+              <a:buNone/>
+            </a:pPr>
+            <a:r>
+              <a:rPr lang="en-US" sz="1250" dirty="0">
                 <a:solidFill>
                   <a:srgbClr val="28251D"/>
                 </a:solidFill>
@@ -2601,76 +2804,36 @@
                 <a:ea typeface="Calibri" pitchFamily="34" charset="-122"/>
                 <a:cs typeface="Calibri" pitchFamily="34" charset="-120"/>
               </a:rPr>
-              <a:t>OpenFlights route data is historical.</a:t>
-            </a:r>
-            <a:endParaRPr lang="en-US" sz="1350" dirty="0"/>
-          </a:p>
-          <a:p>
-            <a:r>
-              <a:rPr lang="en-US" sz="1350" dirty="0">
-                <a:solidFill>
-                  <a:srgbClr val="28251D"/>
-                </a:solidFill>
-                <a:latin typeface="Calibri" pitchFamily="34" charset="0"/>
-                <a:ea typeface="Calibri" pitchFamily="34" charset="-122"/>
-                <a:cs typeface="Calibri" pitchFamily="34" charset="-120"/>
-              </a:rPr>
-              <a:t>Binary matrix does not measure passenger volume.</a:t>
-            </a:r>
-            <a:endParaRPr lang="en-US" sz="1350" dirty="0"/>
-          </a:p>
-          <a:p>
-            <a:r>
-              <a:rPr lang="en-US" sz="1350" dirty="0">
-                <a:solidFill>
-                  <a:srgbClr val="28251D"/>
-                </a:solidFill>
-                <a:latin typeface="Calibri" pitchFamily="34" charset="0"/>
-                <a:ea typeface="Calibri" pitchFamily="34" charset="-122"/>
-                <a:cs typeface="Calibri" pitchFamily="34" charset="-120"/>
-              </a:rPr>
-              <a:t>All outgoing routes are treated as equally likely.</a:t>
-            </a:r>
-            <a:endParaRPr lang="en-US" sz="1350" dirty="0"/>
-          </a:p>
-          <a:p>
-            <a:r>
-              <a:rPr lang="en-US" sz="1350" dirty="0">
-                <a:solidFill>
-                  <a:srgbClr val="28251D"/>
-                </a:solidFill>
-                <a:latin typeface="Calibri" pitchFamily="34" charset="0"/>
-                <a:ea typeface="Calibri" pitchFamily="34" charset="-122"/>
-                <a:cs typeface="Calibri" pitchFamily="34" charset="-120"/>
-              </a:rPr>
-              <a:t>The ATL scenario is a complete closure, not a partial disruption.</a:t>
-            </a:r>
-            <a:endParaRPr lang="en-US" sz="1350" dirty="0"/>
-          </a:p>
-        </p:txBody>
-      </p:sp>
-      <p:sp>
-        <p:nvSpPr>
-          <p:cNvPr id="7" name="Shape 5"/>
-          <p:cNvSpPr/>
-          <p:nvPr/>
-        </p:nvSpPr>
-        <p:spPr>
-          <a:xfrm>
-            <a:off x="6309360" y="1234440"/>
-            <a:ext cx="5166360" cy="3429000"/>
+              <a:t>Top hubs stay the same for d = 0.65 through 0.95. The ranking reflects network structure, not the choice of d.</a:t>
+            </a:r>
+            <a:endParaRPr lang="en-US" sz="1250" dirty="0"/>
+          </a:p>
+        </p:txBody>
+      </p:sp>
+      <p:sp>
+        <p:nvSpPr>
+          <p:cNvPr id="10" name="Shape 8"/>
+          <p:cNvSpPr/>
+          <p:nvPr/>
+        </p:nvSpPr>
+        <p:spPr>
+          <a:xfrm>
+            <a:off x="6355080" y="1325880"/>
+            <a:ext cx="2788920" cy="2606040"/>
           </a:xfrm>
           <a:prstGeom prst="roundRect">
             <a:avLst>
-              <a:gd name="adj" fmla="val 2133"/>
+              <a:gd name="adj" fmla="val 2807"/>
             </a:avLst>
           </a:prstGeom>
           <a:solidFill>
-            <a:srgbClr val="E9F3F3"/>
+            <a:srgbClr val="FBFBF9"/>
           </a:solidFill>
           <a:ln w="12700">
             <a:solidFill>
-              <a:srgbClr val="D4D1CA"/>
+              <a:srgbClr val="D4D1CA">
+                <a:alpha val="90000"/>
+              </a:srgbClr>
             </a:solidFill>
             <a:prstDash val="solid"/>
           </a:ln>
@@ -2678,68 +2841,71 @@
       </p:sp>
       <p:sp>
         <p:nvSpPr>
-          <p:cNvPr id="8" name="Text 6"/>
-          <p:cNvSpPr/>
-          <p:nvPr/>
-        </p:nvSpPr>
-        <p:spPr>
-          <a:xfrm>
-            <a:off x="6629400" y="1554480"/>
-            <a:ext cx="1920240" cy="256032"/>
-          </a:xfrm>
-          <a:prstGeom prst="rect">
-            <a:avLst/>
-          </a:prstGeom>
-          <a:noFill/>
-          <a:ln/>
-        </p:spPr>
-        <p:txBody>
-          <a:bodyPr wrap="square" lIns="0" tIns="0" rIns="0" bIns="0" rtlCol="0" anchor="ctr"/>
-          <a:lstStyle/>
-          <a:p>
-            <a:pPr indent="0" marL="0">
-              <a:buNone/>
-            </a:pPr>
-            <a:r>
-              <a:rPr lang="en-US" sz="1700" b="1" dirty="0">
-                <a:solidFill>
-                  <a:srgbClr val="01696F"/>
+          <p:cNvPr id="11" name="Text 9"/>
+          <p:cNvSpPr/>
+          <p:nvPr/>
+        </p:nvSpPr>
+        <p:spPr>
+          <a:xfrm>
+            <a:off x="6556248" y="1490472"/>
+            <a:ext cx="2386584" cy="228600"/>
+          </a:xfrm>
+          <a:prstGeom prst="rect">
+            <a:avLst/>
+          </a:prstGeom>
+          <a:noFill/>
+          <a:ln/>
+        </p:spPr>
+        <p:txBody>
+          <a:bodyPr wrap="square" lIns="0" tIns="0" rIns="0" bIns="0" rtlCol="0" anchor="ctr"/>
+          <a:lstStyle/>
+          <a:p>
+            <a:pPr indent="0" marL="0">
+              <a:buNone/>
+            </a:pPr>
+            <a:r>
+              <a:rPr lang="en-US" sz="1400" b="1" dirty="0">
+                <a:solidFill>
+                  <a:srgbClr val="28251D"/>
                 </a:solidFill>
                 <a:latin typeface="Trebuchet MS" pitchFamily="34" charset="0"/>
                 <a:ea typeface="Trebuchet MS" pitchFamily="34" charset="-122"/>
                 <a:cs typeface="Trebuchet MS" pitchFamily="34" charset="-120"/>
               </a:rPr>
-              <a:t>Extensions</a:t>
-            </a:r>
-            <a:endParaRPr lang="en-US" sz="1700" dirty="0"/>
-          </a:p>
-        </p:txBody>
-      </p:sp>
-      <p:sp>
-        <p:nvSpPr>
-          <p:cNvPr id="9" name="Text 7"/>
-          <p:cNvSpPr/>
-          <p:nvPr/>
-        </p:nvSpPr>
-        <p:spPr>
-          <a:xfrm>
-            <a:off x="6629400" y="1965960"/>
-            <a:ext cx="4251960" cy="2011680"/>
-          </a:xfrm>
-          <a:prstGeom prst="rect">
-            <a:avLst/>
-          </a:prstGeom>
-          <a:noFill/>
-          <a:ln/>
-        </p:spPr>
-        <p:txBody>
-          <a:bodyPr wrap="square" lIns="635" tIns="635" rIns="635" bIns="635" rtlCol="0" anchor="ctr">
+              <a:t>3. The network is resilient</a:t>
+            </a:r>
+            <a:endParaRPr lang="en-US" sz="1400" dirty="0"/>
+          </a:p>
+        </p:txBody>
+      </p:sp>
+      <p:sp>
+        <p:nvSpPr>
+          <p:cNvPr id="12" name="Text 10"/>
+          <p:cNvSpPr/>
+          <p:nvPr/>
+        </p:nvSpPr>
+        <p:spPr>
+          <a:xfrm>
+            <a:off x="6556248" y="1828800"/>
+            <a:ext cx="2386584" cy="1920240"/>
+          </a:xfrm>
+          <a:prstGeom prst="rect">
+            <a:avLst/>
+          </a:prstGeom>
+          <a:noFill/>
+          <a:ln/>
+        </p:spPr>
+        <p:txBody>
+          <a:bodyPr wrap="square" lIns="254" tIns="254" rIns="254" bIns="254" rtlCol="0" anchor="t">
             <a:normAutofit/>
           </a:bodyPr>
           <a:lstStyle/>
           <a:p>
-            <a:r>
-              <a:rPr lang="en-US" sz="1350" dirty="0">
+            <a:pPr indent="0" marL="0">
+              <a:buNone/>
+            </a:pPr>
+            <a:r>
+              <a:rPr lang="en-US" sz="1250" dirty="0">
                 <a:solidFill>
                   <a:srgbClr val="28251D"/>
                 </a:solidFill>
@@ -2747,27 +2913,108 @@
                 <a:ea typeface="Calibri" pitchFamily="34" charset="-122"/>
                 <a:cs typeface="Calibri" pitchFamily="34" charset="-120"/>
               </a:rPr>
-              <a:t>Use BTS T-100 data to weight edges by passengers or flight counts.</a:t>
-            </a:r>
-            <a:endParaRPr lang="en-US" sz="1350" dirty="0"/>
-          </a:p>
-          <a:p>
-            <a:r>
-              <a:rPr lang="en-US" sz="1350" dirty="0">
+              <a:t>Removing ATL changes rankings, but other hubs absorb importance. The national structure stays connected through multiple hubs.</a:t>
+            </a:r>
+            <a:endParaRPr lang="en-US" sz="1250" dirty="0"/>
+          </a:p>
+        </p:txBody>
+      </p:sp>
+      <p:sp>
+        <p:nvSpPr>
+          <p:cNvPr id="13" name="Shape 11"/>
+          <p:cNvSpPr/>
+          <p:nvPr/>
+        </p:nvSpPr>
+        <p:spPr>
+          <a:xfrm>
+            <a:off x="9281160" y="1325880"/>
+            <a:ext cx="2788920" cy="2606040"/>
+          </a:xfrm>
+          <a:prstGeom prst="roundRect">
+            <a:avLst>
+              <a:gd name="adj" fmla="val 2807"/>
+            </a:avLst>
+          </a:prstGeom>
+          <a:solidFill>
+            <a:srgbClr val="FBFBF9"/>
+          </a:solidFill>
+          <a:ln w="12700">
+            <a:solidFill>
+              <a:srgbClr val="D4D1CA">
+                <a:alpha val="90000"/>
+              </a:srgbClr>
+            </a:solidFill>
+            <a:prstDash val="solid"/>
+          </a:ln>
+        </p:spPr>
+      </p:sp>
+      <p:sp>
+        <p:nvSpPr>
+          <p:cNvPr id="14" name="Text 12"/>
+          <p:cNvSpPr/>
+          <p:nvPr/>
+        </p:nvSpPr>
+        <p:spPr>
+          <a:xfrm>
+            <a:off x="9482328" y="1490472"/>
+            <a:ext cx="2386584" cy="228600"/>
+          </a:xfrm>
+          <a:prstGeom prst="rect">
+            <a:avLst/>
+          </a:prstGeom>
+          <a:noFill/>
+          <a:ln/>
+        </p:spPr>
+        <p:txBody>
+          <a:bodyPr wrap="square" lIns="0" tIns="0" rIns="0" bIns="0" rtlCol="0" anchor="ctr"/>
+          <a:lstStyle/>
+          <a:p>
+            <a:pPr indent="0" marL="0">
+              <a:buNone/>
+            </a:pPr>
+            <a:r>
+              <a:rPr lang="en-US" sz="1400" b="1" dirty="0">
                 <a:solidFill>
                   <a:srgbClr val="28251D"/>
                 </a:solidFill>
-                <a:latin typeface="Calibri" pitchFamily="34" charset="0"/>
-                <a:ea typeface="Calibri" pitchFamily="34" charset="-122"/>
-                <a:cs typeface="Calibri" pitchFamily="34" charset="-120"/>
-              </a:rPr>
-              <a:t>Compare PageRank with degree, betweenness, and eigenvector centrality.</a:t>
-            </a:r>
-            <a:endParaRPr lang="en-US" sz="1350" dirty="0"/>
-          </a:p>
-          <a:p>
-            <a:r>
-              <a:rPr lang="en-US" sz="1350" dirty="0">
+                <a:latin typeface="Trebuchet MS" pitchFamily="34" charset="0"/>
+                <a:ea typeface="Trebuchet MS" pitchFamily="34" charset="-122"/>
+                <a:cs typeface="Trebuchet MS" pitchFamily="34" charset="-120"/>
+              </a:rPr>
+              <a:t>4. Local vulnerability remains</a:t>
+            </a:r>
+            <a:endParaRPr lang="en-US" sz="1400" dirty="0"/>
+          </a:p>
+        </p:txBody>
+      </p:sp>
+      <p:sp>
+        <p:nvSpPr>
+          <p:cNvPr id="15" name="Text 13"/>
+          <p:cNvSpPr/>
+          <p:nvPr/>
+        </p:nvSpPr>
+        <p:spPr>
+          <a:xfrm>
+            <a:off x="9482328" y="1828800"/>
+            <a:ext cx="2386584" cy="1920240"/>
+          </a:xfrm>
+          <a:prstGeom prst="rect">
+            <a:avLst/>
+          </a:prstGeom>
+          <a:noFill/>
+          <a:ln/>
+        </p:spPr>
+        <p:txBody>
+          <a:bodyPr wrap="square" lIns="254" tIns="254" rIns="254" bIns="254" rtlCol="0" anchor="t">
+            <a:normAutofit/>
+          </a:bodyPr>
+          <a:lstStyle/>
+          <a:p>
+            <a:pPr indent="0" marL="0">
+              <a:buNone/>
+            </a:pPr>
+            <a:r>
+              <a:rPr lang="en-US" sz="1250" dirty="0">
                 <a:solidFill>
                   <a:srgbClr val="28251D"/>
                 </a:solidFill>
@@ -2775,29 +3022,54 @@
                 <a:ea typeface="Calibri" pitchFamily="34" charset="-122"/>
                 <a:cs typeface="Calibri" pitchFamily="34" charset="-120"/>
               </a:rPr>
-              <a:t>Simulate multiple hub closures.</a:t>
-            </a:r>
-            <a:endParaRPr lang="en-US" sz="1350" dirty="0"/>
-          </a:p>
-          <a:p>
-            <a:r>
-              <a:rPr lang="en-US" sz="1350" dirty="0">
-                <a:solidFill>
-                  <a:srgbClr val="28251D"/>
-                </a:solidFill>
-                <a:latin typeface="Calibri" pitchFamily="34" charset="0"/>
-                <a:ea typeface="Calibri" pitchFamily="34" charset="-122"/>
-                <a:cs typeface="Calibri" pitchFamily="34" charset="-120"/>
-              </a:rPr>
-              <a:t>Map centrality shifts geographically.</a:t>
-            </a:r>
-            <a:endParaRPr lang="en-US" sz="1350" dirty="0"/>
-          </a:p>
-        </p:txBody>
-      </p:sp>
-      <p:sp>
-        <p:nvSpPr>
-          <p:cNvPr id="10" name="Text 8"/>
+              <a:t>Some regional airports lose importance when ATL is removed, showing that local dependence can be high even if the full network is resilient.</a:t>
+            </a:r>
+            <a:endParaRPr lang="en-US" sz="1250" dirty="0"/>
+          </a:p>
+        </p:txBody>
+      </p:sp>
+      <p:sp>
+        <p:nvSpPr>
+          <p:cNvPr id="16" name="Text 14"/>
+          <p:cNvSpPr/>
+          <p:nvPr/>
+        </p:nvSpPr>
+        <p:spPr>
+          <a:xfrm>
+            <a:off x="914400" y="4800600"/>
+            <a:ext cx="10332720" cy="384048"/>
+          </a:xfrm>
+          <a:prstGeom prst="rect">
+            <a:avLst/>
+          </a:prstGeom>
+          <a:noFill/>
+          <a:ln/>
+        </p:spPr>
+        <p:txBody>
+          <a:bodyPr wrap="square" lIns="0" tIns="0" rIns="0" bIns="0" rtlCol="0" anchor="ctr"/>
+          <a:lstStyle/>
+          <a:p>
+            <a:pPr algn="ctr" indent="0" marL="0">
+              <a:buNone/>
+            </a:pPr>
+            <a:r>
+              <a:rPr lang="en-US" sz="1800" b="1" dirty="0">
+                <a:solidFill>
+                  <a:srgbClr val="01696F"/>
+                </a:solidFill>
+                <a:latin typeface="Calibri" pitchFamily="34" charset="0"/>
+                <a:ea typeface="Calibri" pitchFamily="34" charset="-122"/>
+                <a:cs typeface="Calibri" pitchFamily="34" charset="-120"/>
+              </a:rPr>
+              <a:t>PageRank gives a linear algebra-based way to quantify both structural importance and disruption response.</a:t>
+            </a:r>
+            <a:endParaRPr lang="en-US" sz="1800" dirty="0"/>
+          </a:p>
+        </p:txBody>
+      </p:sp>
+      <p:sp>
+        <p:nvSpPr>
+          <p:cNvPr id="17" name="Text 15"/>
           <p:cNvSpPr/>
           <p:nvPr/>
         </p:nvSpPr>
@@ -2892,7 +3164,7 @@
       </p:sp>
       <p:sp>
         <p:nvSpPr>
-          <p:cNvPr id="11" name="Text 9"/>
+          <p:cNvPr id="18" name="Text 16"/>
           <p:cNvSpPr/>
           <p:nvPr/>
         </p:nvSpPr>
@@ -2940,6 +3212,542 @@
 <file path=ppt/slides/slide11.xml><?xml version="1.0" encoding="utf-8"?>
 <p:sld xmlns:a="http://schemas.openxmlformats.org/drawingml/2006/main" xmlns:r="http://schemas.openxmlformats.org/officeDocument/2006/relationships" xmlns:p="http://schemas.openxmlformats.org/presentationml/2006/main">
   <p:cSld name="Slide 11">
+    <p:bg>
+      <p:bgPr>
+        <a:solidFill>
+          <a:srgbClr val="F7F6F2"/>
+        </a:solidFill>
+      </p:bgPr>
+    </p:bg>
+    <p:spTree>
+      <p:nvGrpSpPr>
+        <p:cNvPr id="1" name=""/>
+        <p:cNvGrpSpPr/>
+        <p:nvPr/>
+      </p:nvGrpSpPr>
+      <p:grpSpPr>
+        <a:xfrm>
+          <a:off x="0" y="0"/>
+          <a:ext cx="0" cy="0"/>
+          <a:chOff x="0" y="0"/>
+          <a:chExt cx="0" cy="0"/>
+        </a:xfrm>
+      </p:grpSpPr>
+      <p:sp>
+        <p:nvSpPr>
+          <p:cNvPr id="2" name="Text 0"/>
+          <p:cNvSpPr/>
+          <p:nvPr/>
+        </p:nvSpPr>
+        <p:spPr>
+          <a:xfrm>
+            <a:off x="502920" y="320040"/>
+            <a:ext cx="7863840" cy="411480"/>
+          </a:xfrm>
+          <a:prstGeom prst="rect">
+            <a:avLst/>
+          </a:prstGeom>
+          <a:noFill/>
+          <a:ln/>
+        </p:spPr>
+        <p:txBody>
+          <a:bodyPr wrap="square" lIns="0" tIns="0" rIns="0" bIns="0" rtlCol="0" anchor="ctr"/>
+          <a:lstStyle/>
+          <a:p>
+            <a:pPr indent="0" marL="0">
+              <a:buNone/>
+            </a:pPr>
+            <a:r>
+              <a:rPr lang="en-US" sz="2400" b="1" dirty="0">
+                <a:solidFill>
+                  <a:srgbClr val="28251D"/>
+                </a:solidFill>
+                <a:latin typeface="Trebuchet MS" pitchFamily="34" charset="0"/>
+                <a:ea typeface="Trebuchet MS" pitchFamily="34" charset="-122"/>
+                <a:cs typeface="Trebuchet MS" pitchFamily="34" charset="-120"/>
+              </a:rPr>
+              <a:t>Limitations and Extensions</a:t>
+            </a:r>
+            <a:endParaRPr lang="en-US" sz="2400" dirty="0"/>
+          </a:p>
+        </p:txBody>
+      </p:sp>
+      <p:sp>
+        <p:nvSpPr>
+          <p:cNvPr id="3" name="Text 1"/>
+          <p:cNvSpPr/>
+          <p:nvPr/>
+        </p:nvSpPr>
+        <p:spPr>
+          <a:xfrm>
+            <a:off x="502920" y="786384"/>
+            <a:ext cx="9692640" cy="228600"/>
+          </a:xfrm>
+          <a:prstGeom prst="rect">
+            <a:avLst/>
+          </a:prstGeom>
+          <a:noFill/>
+          <a:ln/>
+        </p:spPr>
+        <p:txBody>
+          <a:bodyPr wrap="square" lIns="0" tIns="0" rIns="0" bIns="0" rtlCol="0" anchor="ctr"/>
+          <a:lstStyle/>
+          <a:p>
+            <a:pPr indent="0" marL="0">
+              <a:buNone/>
+            </a:pPr>
+            <a:r>
+              <a:rPr lang="en-US" sz="1050" dirty="0">
+                <a:solidFill>
+                  <a:srgbClr val="7A7974"/>
+                </a:solidFill>
+                <a:latin typeface="Calibri" pitchFamily="34" charset="0"/>
+                <a:ea typeface="Calibri" pitchFamily="34" charset="-122"/>
+                <a:cs typeface="Calibri" pitchFamily="34" charset="-120"/>
+              </a:rPr>
+              <a:t>How the project could be strengthened</a:t>
+            </a:r>
+            <a:endParaRPr lang="en-US" sz="1050" dirty="0"/>
+          </a:p>
+        </p:txBody>
+      </p:sp>
+      <p:sp>
+        <p:nvSpPr>
+          <p:cNvPr id="4" name="Shape 2"/>
+          <p:cNvSpPr/>
+          <p:nvPr/>
+        </p:nvSpPr>
+        <p:spPr>
+          <a:xfrm>
+            <a:off x="731520" y="1234440"/>
+            <a:ext cx="5166360" cy="3429000"/>
+          </a:xfrm>
+          <a:prstGeom prst="roundRect">
+            <a:avLst>
+              <a:gd name="adj" fmla="val 2133"/>
+            </a:avLst>
+          </a:prstGeom>
+          <a:solidFill>
+            <a:srgbClr val="FBFBF9"/>
+          </a:solidFill>
+          <a:ln w="12700">
+            <a:solidFill>
+              <a:srgbClr val="D4D1CA"/>
+            </a:solidFill>
+            <a:prstDash val="solid"/>
+          </a:ln>
+        </p:spPr>
+      </p:sp>
+      <p:sp>
+        <p:nvSpPr>
+          <p:cNvPr id="5" name="Text 3"/>
+          <p:cNvSpPr/>
+          <p:nvPr/>
+        </p:nvSpPr>
+        <p:spPr>
+          <a:xfrm>
+            <a:off x="1051560" y="1554480"/>
+            <a:ext cx="1920240" cy="256032"/>
+          </a:xfrm>
+          <a:prstGeom prst="rect">
+            <a:avLst/>
+          </a:prstGeom>
+          <a:noFill/>
+          <a:ln/>
+        </p:spPr>
+        <p:txBody>
+          <a:bodyPr wrap="square" lIns="0" tIns="0" rIns="0" bIns="0" rtlCol="0" anchor="ctr"/>
+          <a:lstStyle/>
+          <a:p>
+            <a:pPr indent="0" marL="0">
+              <a:buNone/>
+            </a:pPr>
+            <a:r>
+              <a:rPr lang="en-US" sz="1700" b="1" dirty="0">
+                <a:solidFill>
+                  <a:srgbClr val="28251D"/>
+                </a:solidFill>
+                <a:latin typeface="Trebuchet MS" pitchFamily="34" charset="0"/>
+                <a:ea typeface="Trebuchet MS" pitchFamily="34" charset="-122"/>
+                <a:cs typeface="Trebuchet MS" pitchFamily="34" charset="-120"/>
+              </a:rPr>
+              <a:t>Limitations</a:t>
+            </a:r>
+            <a:endParaRPr lang="en-US" sz="1700" dirty="0"/>
+          </a:p>
+        </p:txBody>
+      </p:sp>
+      <p:sp>
+        <p:nvSpPr>
+          <p:cNvPr id="6" name="Text 4"/>
+          <p:cNvSpPr/>
+          <p:nvPr/>
+        </p:nvSpPr>
+        <p:spPr>
+          <a:xfrm>
+            <a:off x="1051560" y="1965960"/>
+            <a:ext cx="4251960" cy="2011680"/>
+          </a:xfrm>
+          <a:prstGeom prst="rect">
+            <a:avLst/>
+          </a:prstGeom>
+          <a:noFill/>
+          <a:ln/>
+        </p:spPr>
+        <p:txBody>
+          <a:bodyPr wrap="square" lIns="635" tIns="635" rIns="635" bIns="635" rtlCol="0" anchor="ctr">
+            <a:normAutofit/>
+          </a:bodyPr>
+          <a:lstStyle/>
+          <a:p>
+            <a:r>
+              <a:rPr lang="en-US" sz="1350" dirty="0">
+                <a:solidFill>
+                  <a:srgbClr val="28251D"/>
+                </a:solidFill>
+                <a:latin typeface="Calibri" pitchFamily="34" charset="0"/>
+                <a:ea typeface="Calibri" pitchFamily="34" charset="-122"/>
+                <a:cs typeface="Calibri" pitchFamily="34" charset="-120"/>
+              </a:rPr>
+              <a:t>OpenFlights route data is historical.</a:t>
+            </a:r>
+            <a:endParaRPr lang="en-US" sz="1350" dirty="0"/>
+          </a:p>
+          <a:p>
+            <a:r>
+              <a:rPr lang="en-US" sz="1350" dirty="0">
+                <a:solidFill>
+                  <a:srgbClr val="28251D"/>
+                </a:solidFill>
+                <a:latin typeface="Calibri" pitchFamily="34" charset="0"/>
+                <a:ea typeface="Calibri" pitchFamily="34" charset="-122"/>
+                <a:cs typeface="Calibri" pitchFamily="34" charset="-120"/>
+              </a:rPr>
+              <a:t>Binary matrix does not measure passenger volume.</a:t>
+            </a:r>
+            <a:endParaRPr lang="en-US" sz="1350" dirty="0"/>
+          </a:p>
+          <a:p>
+            <a:r>
+              <a:rPr lang="en-US" sz="1350" dirty="0">
+                <a:solidFill>
+                  <a:srgbClr val="28251D"/>
+                </a:solidFill>
+                <a:latin typeface="Calibri" pitchFamily="34" charset="0"/>
+                <a:ea typeface="Calibri" pitchFamily="34" charset="-122"/>
+                <a:cs typeface="Calibri" pitchFamily="34" charset="-120"/>
+              </a:rPr>
+              <a:t>All outgoing routes are treated as equally likely.</a:t>
+            </a:r>
+            <a:endParaRPr lang="en-US" sz="1350" dirty="0"/>
+          </a:p>
+          <a:p>
+            <a:r>
+              <a:rPr lang="en-US" sz="1350" dirty="0">
+                <a:solidFill>
+                  <a:srgbClr val="28251D"/>
+                </a:solidFill>
+                <a:latin typeface="Calibri" pitchFamily="34" charset="0"/>
+                <a:ea typeface="Calibri" pitchFamily="34" charset="-122"/>
+                <a:cs typeface="Calibri" pitchFamily="34" charset="-120"/>
+              </a:rPr>
+              <a:t>The ATL scenario is a complete closure, not a partial disruption.</a:t>
+            </a:r>
+            <a:endParaRPr lang="en-US" sz="1350" dirty="0"/>
+          </a:p>
+        </p:txBody>
+      </p:sp>
+      <p:sp>
+        <p:nvSpPr>
+          <p:cNvPr id="7" name="Shape 5"/>
+          <p:cNvSpPr/>
+          <p:nvPr/>
+        </p:nvSpPr>
+        <p:spPr>
+          <a:xfrm>
+            <a:off x="6309360" y="1234440"/>
+            <a:ext cx="5166360" cy="3429000"/>
+          </a:xfrm>
+          <a:prstGeom prst="roundRect">
+            <a:avLst>
+              <a:gd name="adj" fmla="val 2133"/>
+            </a:avLst>
+          </a:prstGeom>
+          <a:solidFill>
+            <a:srgbClr val="E9F3F3"/>
+          </a:solidFill>
+          <a:ln w="12700">
+            <a:solidFill>
+              <a:srgbClr val="D4D1CA"/>
+            </a:solidFill>
+            <a:prstDash val="solid"/>
+          </a:ln>
+        </p:spPr>
+      </p:sp>
+      <p:sp>
+        <p:nvSpPr>
+          <p:cNvPr id="8" name="Text 6"/>
+          <p:cNvSpPr/>
+          <p:nvPr/>
+        </p:nvSpPr>
+        <p:spPr>
+          <a:xfrm>
+            <a:off x="6629400" y="1554480"/>
+            <a:ext cx="1920240" cy="256032"/>
+          </a:xfrm>
+          <a:prstGeom prst="rect">
+            <a:avLst/>
+          </a:prstGeom>
+          <a:noFill/>
+          <a:ln/>
+        </p:spPr>
+        <p:txBody>
+          <a:bodyPr wrap="square" lIns="0" tIns="0" rIns="0" bIns="0" rtlCol="0" anchor="ctr"/>
+          <a:lstStyle/>
+          <a:p>
+            <a:pPr indent="0" marL="0">
+              <a:buNone/>
+            </a:pPr>
+            <a:r>
+              <a:rPr lang="en-US" sz="1700" b="1" dirty="0">
+                <a:solidFill>
+                  <a:srgbClr val="01696F"/>
+                </a:solidFill>
+                <a:latin typeface="Trebuchet MS" pitchFamily="34" charset="0"/>
+                <a:ea typeface="Trebuchet MS" pitchFamily="34" charset="-122"/>
+                <a:cs typeface="Trebuchet MS" pitchFamily="34" charset="-120"/>
+              </a:rPr>
+              <a:t>Extensions</a:t>
+            </a:r>
+            <a:endParaRPr lang="en-US" sz="1700" dirty="0"/>
+          </a:p>
+        </p:txBody>
+      </p:sp>
+      <p:sp>
+        <p:nvSpPr>
+          <p:cNvPr id="9" name="Text 7"/>
+          <p:cNvSpPr/>
+          <p:nvPr/>
+        </p:nvSpPr>
+        <p:spPr>
+          <a:xfrm>
+            <a:off x="6629400" y="1965960"/>
+            <a:ext cx="4251960" cy="2011680"/>
+          </a:xfrm>
+          <a:prstGeom prst="rect">
+            <a:avLst/>
+          </a:prstGeom>
+          <a:noFill/>
+          <a:ln/>
+        </p:spPr>
+        <p:txBody>
+          <a:bodyPr wrap="square" lIns="635" tIns="635" rIns="635" bIns="635" rtlCol="0" anchor="ctr">
+            <a:normAutofit/>
+          </a:bodyPr>
+          <a:lstStyle/>
+          <a:p>
+            <a:r>
+              <a:rPr lang="en-US" sz="1350" dirty="0">
+                <a:solidFill>
+                  <a:srgbClr val="28251D"/>
+                </a:solidFill>
+                <a:latin typeface="Calibri" pitchFamily="34" charset="0"/>
+                <a:ea typeface="Calibri" pitchFamily="34" charset="-122"/>
+                <a:cs typeface="Calibri" pitchFamily="34" charset="-120"/>
+              </a:rPr>
+              <a:t>Use BTS T-100 data to weight edges by passengers or flight counts.</a:t>
+            </a:r>
+            <a:endParaRPr lang="en-US" sz="1350" dirty="0"/>
+          </a:p>
+          <a:p>
+            <a:r>
+              <a:rPr lang="en-US" sz="1350" dirty="0">
+                <a:solidFill>
+                  <a:srgbClr val="28251D"/>
+                </a:solidFill>
+                <a:latin typeface="Calibri" pitchFamily="34" charset="0"/>
+                <a:ea typeface="Calibri" pitchFamily="34" charset="-122"/>
+                <a:cs typeface="Calibri" pitchFamily="34" charset="-120"/>
+              </a:rPr>
+              <a:t>Compare PageRank with degree, betweenness, and eigenvector centrality.</a:t>
+            </a:r>
+            <a:endParaRPr lang="en-US" sz="1350" dirty="0"/>
+          </a:p>
+          <a:p>
+            <a:r>
+              <a:rPr lang="en-US" sz="1350" dirty="0">
+                <a:solidFill>
+                  <a:srgbClr val="28251D"/>
+                </a:solidFill>
+                <a:latin typeface="Calibri" pitchFamily="34" charset="0"/>
+                <a:ea typeface="Calibri" pitchFamily="34" charset="-122"/>
+                <a:cs typeface="Calibri" pitchFamily="34" charset="-120"/>
+              </a:rPr>
+              <a:t>Simulate multiple hub closures.</a:t>
+            </a:r>
+            <a:endParaRPr lang="en-US" sz="1350" dirty="0"/>
+          </a:p>
+          <a:p>
+            <a:r>
+              <a:rPr lang="en-US" sz="1350" dirty="0">
+                <a:solidFill>
+                  <a:srgbClr val="28251D"/>
+                </a:solidFill>
+                <a:latin typeface="Calibri" pitchFamily="34" charset="0"/>
+                <a:ea typeface="Calibri" pitchFamily="34" charset="-122"/>
+                <a:cs typeface="Calibri" pitchFamily="34" charset="-120"/>
+              </a:rPr>
+              <a:t>Map centrality shifts geographically.</a:t>
+            </a:r>
+            <a:endParaRPr lang="en-US" sz="1350" dirty="0"/>
+          </a:p>
+        </p:txBody>
+      </p:sp>
+      <p:sp>
+        <p:nvSpPr>
+          <p:cNvPr id="10" name="Text 8"/>
+          <p:cNvSpPr/>
+          <p:nvPr/>
+        </p:nvSpPr>
+        <p:spPr>
+          <a:xfrm>
+            <a:off x="502920" y="6419088"/>
+            <a:ext cx="4846320" cy="219456"/>
+          </a:xfrm>
+          <a:prstGeom prst="rect">
+            <a:avLst/>
+          </a:prstGeom>
+          <a:noFill/>
+          <a:ln/>
+        </p:spPr>
+        <p:txBody>
+          <a:bodyPr wrap="square" lIns="0" tIns="0" rIns="0" bIns="0" rtlCol="0" anchor="ctr"/>
+          <a:lstStyle/>
+          <a:p>
+            <a:pPr indent="0" marL="0">
+              <a:buNone/>
+            </a:pPr>
+            <a:r>
+              <a:rPr lang="en-US" sz="900" dirty="0">
+                <a:solidFill>
+                  <a:srgbClr val="5A5952"/>
+                </a:solidFill>
+                <a:latin typeface="Calibri" pitchFamily="34" charset="0"/>
+                <a:ea typeface="Calibri" pitchFamily="34" charset="-122"/>
+                <a:cs typeface="Calibri" pitchFamily="34" charset="-120"/>
+              </a:rPr>
+              <a:t>Source: </a:t>
+            </a:r>
+            <a:pPr indent="0" marL="0">
+              <a:buNone/>
+            </a:pPr>
+            <a:r>
+              <a:rPr lang="en-US" sz="900" u="sng" dirty="0">
+                <a:solidFill>
+                  <a:srgbClr val="5A5952"/>
+                </a:solidFill>
+                <a:latin typeface="Calibri" pitchFamily="34" charset="0"/>
+                <a:ea typeface="Calibri" pitchFamily="34" charset="-122"/>
+                <a:cs typeface="Calibri" pitchFamily="34" charset="-120"/>
+                <a:hlinkClick r:id="rId1" invalidUrl="" action="" tgtFrame="" tooltip="" history="1" highlightClick="0" endSnd="0">
+                  <a:extLst>
+                    <a:ext uri="{A12FA001-AC4F-418D-AE19-62706E023703}">
+                      <ahyp:hlinkClr xmlns:ahyp="http://schemas.microsoft.com/office/drawing/2018/hyperlinkcolor" val="tx"/>
+                    </a:ext>
+                  </a:extLst>
+                </a:hlinkClick>
+              </a:rPr>
+              <a:t>OpenFlights</a:t>
+            </a:r>
+            <a:pPr indent="0" marL="0">
+              <a:buNone/>
+            </a:pPr>
+            <a:r>
+              <a:rPr lang="en-US" sz="900" dirty="0">
+                <a:solidFill>
+                  <a:srgbClr val="5A5952"/>
+                </a:solidFill>
+                <a:latin typeface="Calibri" pitchFamily="34" charset="0"/>
+                <a:ea typeface="Calibri" pitchFamily="34" charset="-122"/>
+                <a:cs typeface="Calibri" pitchFamily="34" charset="-120"/>
+              </a:rPr>
+              <a:t>; </a:t>
+            </a:r>
+            <a:pPr indent="0" marL="0">
+              <a:buNone/>
+            </a:pPr>
+            <a:r>
+              <a:rPr lang="en-US" sz="900" u="sng" dirty="0">
+                <a:solidFill>
+                  <a:srgbClr val="5A5952"/>
+                </a:solidFill>
+                <a:latin typeface="Calibri" pitchFamily="34" charset="0"/>
+                <a:ea typeface="Calibri" pitchFamily="34" charset="-122"/>
+                <a:cs typeface="Calibri" pitchFamily="34" charset="-120"/>
+                <a:hlinkClick r:id="rId2" invalidUrl="" action="" tgtFrame="" tooltip="" history="1" highlightClick="0" endSnd="0">
+                  <a:extLst>
+                    <a:ext uri="{A12FA001-AC4F-418D-AE19-62706E023703}">
+                      <ahyp:hlinkClr xmlns:ahyp="http://schemas.microsoft.com/office/drawing/2018/hyperlinkcolor" val="tx"/>
+                    </a:ext>
+                  </a:extLst>
+                </a:hlinkClick>
+              </a:rPr>
+              <a:t>project notebook</a:t>
+            </a:r>
+            <a:endParaRPr lang="en-US" sz="900" dirty="0"/>
+          </a:p>
+        </p:txBody>
+      </p:sp>
+      <p:sp>
+        <p:nvSpPr>
+          <p:cNvPr id="11" name="Text 9"/>
+          <p:cNvSpPr/>
+          <p:nvPr/>
+        </p:nvSpPr>
+        <p:spPr>
+          <a:xfrm>
+            <a:off x="11292840" y="6446520"/>
+            <a:ext cx="411480" cy="182880"/>
+          </a:xfrm>
+          <a:prstGeom prst="rect">
+            <a:avLst/>
+          </a:prstGeom>
+          <a:noFill/>
+          <a:ln/>
+        </p:spPr>
+        <p:txBody>
+          <a:bodyPr wrap="square" lIns="0" tIns="0" rIns="0" bIns="0" rtlCol="0" anchor="ctr"/>
+          <a:lstStyle/>
+          <a:p>
+            <a:pPr algn="r" indent="0" marL="0">
+              <a:buNone/>
+            </a:pPr>
+            <a:r>
+              <a:rPr lang="en-US" sz="900" dirty="0">
+                <a:solidFill>
+                  <a:srgbClr val="7A7974"/>
+                </a:solidFill>
+                <a:latin typeface="Calibri" pitchFamily="34" charset="0"/>
+                <a:ea typeface="Calibri" pitchFamily="34" charset="-122"/>
+                <a:cs typeface="Calibri" pitchFamily="34" charset="-120"/>
+              </a:rPr>
+              <a:t>11</a:t>
+            </a:r>
+            <a:endParaRPr lang="en-US" sz="900" dirty="0"/>
+          </a:p>
+        </p:txBody>
+      </p:sp>
+    </p:spTree>
+  </p:cSld>
+  <p:clrMapOvr>
+    <a:masterClrMapping/>
+  </p:clrMapOvr>
+</p:sld>
+</file>
+
+<file path=ppt/slides/slide12.xml><?xml version="1.0" encoding="utf-8"?>
+<p:sld xmlns:a="http://schemas.openxmlformats.org/drawingml/2006/main" xmlns:r="http://schemas.openxmlformats.org/officeDocument/2006/relationships" xmlns:p="http://schemas.openxmlformats.org/presentationml/2006/main">
+  <p:cSld name="Slide 12">
     <p:bg>
       <p:bgPr>
         <a:solidFill>
@@ -3325,7 +4133,7 @@
                 <a:ea typeface="Calibri" pitchFamily="34" charset="-122"/>
                 <a:cs typeface="Calibri" pitchFamily="34" charset="-120"/>
               </a:rPr>
-              <a:t>11</a:t>
+              <a:t>12</a:t>
             </a:r>
             <a:endParaRPr lang="en-US" sz="900" dirty="0"/>
           </a:p>
@@ -6695,7 +7503,7 @@
       </p:sp>
       <p:pic>
         <p:nvPicPr>
-          <p:cNvPr id="4" name="Image 0" descr="/home/user/workspace/Airport_PageRank/figures/top-airports-pagerank.png">    </p:cNvPr>
+          <p:cNvPr id="4" name="Image 0" descr="/tmp/Airport_PageRank/figures/top-airports-pagerank.png">    </p:cNvPr>
           <p:cNvPicPr>
             <a:picLocks noChangeAspect="1"/>
           </p:cNvPicPr>
@@ -7142,7 +7950,7 @@
                 <a:ea typeface="Trebuchet MS" pitchFamily="34" charset="-122"/>
                 <a:cs typeface="Trebuchet MS" pitchFamily="34" charset="-120"/>
               </a:rPr>
-              <a:t>Hub Closure Experiment</a:t>
+              <a:t>Damping Factor Sensitivity</a:t>
             </a:r>
             <a:endParaRPr lang="en-US" sz="2400" dirty="0"/>
           </a:p>
@@ -7181,381 +7989,54 @@
                 <a:ea typeface="Calibri" pitchFamily="34" charset="-122"/>
                 <a:cs typeface="Calibri" pitchFamily="34" charset="-120"/>
               </a:rPr>
-              <a:t>What happens when ATL is removed?</a:t>
+              <a:t>Are the top hubs stable across choices of d?</a:t>
             </a:r>
             <a:endParaRPr lang="en-US" sz="1050" dirty="0"/>
           </a:p>
         </p:txBody>
       </p:sp>
-      <p:sp>
-        <p:nvSpPr>
-          <p:cNvPr id="4" name="Text 2"/>
-          <p:cNvSpPr/>
-          <p:nvPr/>
-        </p:nvSpPr>
-        <p:spPr>
-          <a:xfrm>
-            <a:off x="685800" y="1207008"/>
-            <a:ext cx="9784080" cy="347472"/>
-          </a:xfrm>
-          <a:prstGeom prst="rect">
-            <a:avLst/>
-          </a:prstGeom>
-          <a:noFill/>
-          <a:ln/>
-        </p:spPr>
-        <p:txBody>
-          <a:bodyPr wrap="square" lIns="0" tIns="0" rIns="0" bIns="0" rtlCol="0" anchor="ctr"/>
-          <a:lstStyle/>
-          <a:p>
-            <a:pPr indent="0" marL="0">
-              <a:buNone/>
-            </a:pPr>
-            <a:r>
-              <a:rPr lang="en-US" sz="1500" dirty="0">
-                <a:solidFill>
-                  <a:srgbClr val="28251D"/>
-                </a:solidFill>
-                <a:latin typeface="Calibri" pitchFamily="34" charset="0"/>
-                <a:ea typeface="Calibri" pitchFamily="34" charset="-122"/>
-                <a:cs typeface="Calibri" pitchFamily="34" charset="-120"/>
-              </a:rPr>
-              <a:t>Simulation: remove all incoming and outgoing ATL routes, rebuild the matrices, and recompute PageRank.</a:t>
-            </a:r>
-            <a:endParaRPr lang="en-US" sz="1500" dirty="0"/>
-          </a:p>
-        </p:txBody>
-      </p:sp>
-      <p:sp>
-        <p:nvSpPr>
-          <p:cNvPr id="5" name="Text 3"/>
-          <p:cNvSpPr/>
-          <p:nvPr/>
-        </p:nvSpPr>
-        <p:spPr>
-          <a:xfrm>
-            <a:off x="868680" y="1874520"/>
-            <a:ext cx="1920240" cy="566928"/>
-          </a:xfrm>
-          <a:prstGeom prst="rect">
-            <a:avLst/>
-          </a:prstGeom>
-          <a:noFill/>
-          <a:ln/>
-        </p:spPr>
-        <p:txBody>
-          <a:bodyPr wrap="square" lIns="0" tIns="0" rIns="0" bIns="0" rtlCol="0" anchor="ctr"/>
-          <a:lstStyle/>
-          <a:p>
-            <a:pPr algn="ctr" indent="0" marL="0">
-              <a:buNone/>
-            </a:pPr>
-            <a:r>
-              <a:rPr lang="en-US" sz="3000" b="1" dirty="0">
-                <a:solidFill>
-                  <a:srgbClr val="A13544"/>
-                </a:solidFill>
-                <a:latin typeface="Trebuchet MS" pitchFamily="34" charset="0"/>
-                <a:ea typeface="Trebuchet MS" pitchFamily="34" charset="-122"/>
-                <a:cs typeface="Trebuchet MS" pitchFamily="34" charset="-120"/>
-              </a:rPr>
-              <a:t>ATL</a:t>
-            </a:r>
-            <a:endParaRPr lang="en-US" sz="3000" dirty="0"/>
-          </a:p>
-        </p:txBody>
-      </p:sp>
-      <p:sp>
-        <p:nvSpPr>
-          <p:cNvPr id="6" name="Text 4"/>
-          <p:cNvSpPr/>
-          <p:nvPr/>
-        </p:nvSpPr>
-        <p:spPr>
-          <a:xfrm>
-            <a:off x="868680" y="2478024"/>
-            <a:ext cx="1920240" cy="274320"/>
-          </a:xfrm>
-          <a:prstGeom prst="rect">
-            <a:avLst/>
-          </a:prstGeom>
-          <a:noFill/>
-          <a:ln/>
-        </p:spPr>
-        <p:txBody>
-          <a:bodyPr wrap="square" lIns="0" tIns="0" rIns="0" bIns="0" rtlCol="0" anchor="ctr"/>
-          <a:lstStyle/>
-          <a:p>
-            <a:pPr algn="ctr" indent="0" marL="0">
-              <a:buNone/>
-            </a:pPr>
-            <a:r>
-              <a:rPr lang="en-US" sz="1050" dirty="0">
-                <a:solidFill>
-                  <a:srgbClr val="7A7974"/>
-                </a:solidFill>
-                <a:latin typeface="Calibri" pitchFamily="34" charset="0"/>
-                <a:ea typeface="Calibri" pitchFamily="34" charset="-122"/>
-                <a:cs typeface="Calibri" pitchFamily="34" charset="-120"/>
-              </a:rPr>
-              <a:t>removed hub</a:t>
-            </a:r>
-            <a:endParaRPr lang="en-US" sz="1050" dirty="0"/>
-          </a:p>
-        </p:txBody>
-      </p:sp>
-      <p:sp>
-        <p:nvSpPr>
-          <p:cNvPr id="7" name="Text 5"/>
-          <p:cNvSpPr/>
-          <p:nvPr/>
-        </p:nvSpPr>
-        <p:spPr>
-          <a:xfrm>
-            <a:off x="3063240" y="1874520"/>
-            <a:ext cx="2240280" cy="566928"/>
-          </a:xfrm>
-          <a:prstGeom prst="rect">
-            <a:avLst/>
-          </a:prstGeom>
-          <a:noFill/>
-          <a:ln/>
-        </p:spPr>
-        <p:txBody>
-          <a:bodyPr wrap="square" lIns="0" tIns="0" rIns="0" bIns="0" rtlCol="0" anchor="ctr"/>
-          <a:lstStyle/>
-          <a:p>
-            <a:pPr algn="ctr" indent="0" marL="0">
-              <a:buNone/>
-            </a:pPr>
-            <a:r>
-              <a:rPr lang="en-US" sz="3000" b="1" dirty="0">
-                <a:solidFill>
-                  <a:srgbClr val="01696F"/>
-                </a:solidFill>
-                <a:latin typeface="Trebuchet MS" pitchFamily="34" charset="0"/>
-                <a:ea typeface="Trebuchet MS" pitchFamily="34" charset="-122"/>
-                <a:cs typeface="Trebuchet MS" pitchFamily="34" charset="-120"/>
-              </a:rPr>
-              <a:t>5,145</a:t>
-            </a:r>
-            <a:endParaRPr lang="en-US" sz="3000" dirty="0"/>
-          </a:p>
-        </p:txBody>
-      </p:sp>
-      <p:sp>
-        <p:nvSpPr>
-          <p:cNvPr id="8" name="Text 6"/>
-          <p:cNvSpPr/>
-          <p:nvPr/>
-        </p:nvSpPr>
-        <p:spPr>
-          <a:xfrm>
-            <a:off x="3063240" y="2478024"/>
-            <a:ext cx="2240280" cy="274320"/>
-          </a:xfrm>
-          <a:prstGeom prst="rect">
-            <a:avLst/>
-          </a:prstGeom>
-          <a:noFill/>
-          <a:ln/>
-        </p:spPr>
-        <p:txBody>
-          <a:bodyPr wrap="square" lIns="0" tIns="0" rIns="0" bIns="0" rtlCol="0" anchor="ctr"/>
-          <a:lstStyle/>
-          <a:p>
-            <a:pPr algn="ctr" indent="0" marL="0">
-              <a:buNone/>
-            </a:pPr>
-            <a:r>
-              <a:rPr lang="en-US" sz="1050" dirty="0">
-                <a:solidFill>
-                  <a:srgbClr val="7A7974"/>
-                </a:solidFill>
-                <a:latin typeface="Calibri" pitchFamily="34" charset="0"/>
-                <a:ea typeface="Calibri" pitchFamily="34" charset="-122"/>
-                <a:cs typeface="Calibri" pitchFamily="34" charset="-120"/>
-              </a:rPr>
-              <a:t>remaining directed routes</a:t>
-            </a:r>
-            <a:endParaRPr lang="en-US" sz="1050" dirty="0"/>
-          </a:p>
-        </p:txBody>
-      </p:sp>
-      <p:sp>
-        <p:nvSpPr>
-          <p:cNvPr id="9" name="Text 7"/>
-          <p:cNvSpPr/>
-          <p:nvPr/>
-        </p:nvSpPr>
-        <p:spPr>
-          <a:xfrm>
-            <a:off x="5559552" y="1874520"/>
-            <a:ext cx="2057400" cy="566928"/>
-          </a:xfrm>
-          <a:prstGeom prst="rect">
-            <a:avLst/>
-          </a:prstGeom>
-          <a:noFill/>
-          <a:ln/>
-        </p:spPr>
-        <p:txBody>
-          <a:bodyPr wrap="square" lIns="0" tIns="0" rIns="0" bIns="0" rtlCol="0" anchor="ctr"/>
-          <a:lstStyle/>
-          <a:p>
-            <a:pPr algn="ctr" indent="0" marL="0">
-              <a:buNone/>
-            </a:pPr>
-            <a:r>
-              <a:rPr lang="en-US" sz="3000" b="1" dirty="0">
-                <a:solidFill>
-                  <a:srgbClr val="01696F"/>
-                </a:solidFill>
-                <a:latin typeface="Trebuchet MS" pitchFamily="34" charset="0"/>
-                <a:ea typeface="Trebuchet MS" pitchFamily="34" charset="-122"/>
-                <a:cs typeface="Trebuchet MS" pitchFamily="34" charset="-120"/>
-              </a:rPr>
-              <a:t>112</a:t>
-            </a:r>
-            <a:endParaRPr lang="en-US" sz="3000" dirty="0"/>
-          </a:p>
-        </p:txBody>
-      </p:sp>
-      <p:sp>
-        <p:nvSpPr>
-          <p:cNvPr id="10" name="Text 8"/>
-          <p:cNvSpPr/>
-          <p:nvPr/>
-        </p:nvSpPr>
-        <p:spPr>
-          <a:xfrm>
-            <a:off x="5559552" y="2478024"/>
-            <a:ext cx="2057400" cy="274320"/>
-          </a:xfrm>
-          <a:prstGeom prst="rect">
-            <a:avLst/>
-          </a:prstGeom>
-          <a:noFill/>
-          <a:ln/>
-        </p:spPr>
-        <p:txBody>
-          <a:bodyPr wrap="square" lIns="0" tIns="0" rIns="0" bIns="0" rtlCol="0" anchor="ctr"/>
-          <a:lstStyle/>
-          <a:p>
-            <a:pPr algn="ctr" indent="0" marL="0">
-              <a:buNone/>
-            </a:pPr>
-            <a:r>
-              <a:rPr lang="en-US" sz="1050" dirty="0">
-                <a:solidFill>
-                  <a:srgbClr val="7A7974"/>
-                </a:solidFill>
-                <a:latin typeface="Calibri" pitchFamily="34" charset="0"/>
-                <a:ea typeface="Calibri" pitchFamily="34" charset="-122"/>
-                <a:cs typeface="Calibri" pitchFamily="34" charset="-120"/>
-              </a:rPr>
-              <a:t>post-closure iterations</a:t>
-            </a:r>
-            <a:endParaRPr lang="en-US" sz="1050" dirty="0"/>
-          </a:p>
-        </p:txBody>
-      </p:sp>
-      <p:sp>
-        <p:nvSpPr>
-          <p:cNvPr id="11" name="Text 9"/>
-          <p:cNvSpPr/>
-          <p:nvPr/>
-        </p:nvSpPr>
-        <p:spPr>
-          <a:xfrm>
-            <a:off x="7909560" y="1874520"/>
-            <a:ext cx="1920240" cy="566928"/>
-          </a:xfrm>
-          <a:prstGeom prst="rect">
-            <a:avLst/>
-          </a:prstGeom>
-          <a:noFill/>
-          <a:ln/>
-        </p:spPr>
-        <p:txBody>
-          <a:bodyPr wrap="square" lIns="0" tIns="0" rIns="0" bIns="0" rtlCol="0" anchor="ctr"/>
-          <a:lstStyle/>
-          <a:p>
-            <a:pPr algn="ctr" indent="0" marL="0">
-              <a:buNone/>
-            </a:pPr>
-            <a:r>
-              <a:rPr lang="en-US" sz="3000" b="1" dirty="0">
-                <a:solidFill>
-                  <a:srgbClr val="01696F"/>
-                </a:solidFill>
-                <a:latin typeface="Trebuchet MS" pitchFamily="34" charset="0"/>
-                <a:ea typeface="Trebuchet MS" pitchFamily="34" charset="-122"/>
-                <a:cs typeface="Trebuchet MS" pitchFamily="34" charset="-120"/>
-              </a:rPr>
-              <a:t>DEN</a:t>
-            </a:r>
-            <a:endParaRPr lang="en-US" sz="3000" dirty="0"/>
-          </a:p>
-        </p:txBody>
-      </p:sp>
-      <p:sp>
-        <p:nvSpPr>
-          <p:cNvPr id="12" name="Text 10"/>
-          <p:cNvSpPr/>
-          <p:nvPr/>
-        </p:nvSpPr>
-        <p:spPr>
-          <a:xfrm>
-            <a:off x="7909560" y="2478024"/>
-            <a:ext cx="1920240" cy="274320"/>
-          </a:xfrm>
-          <a:prstGeom prst="rect">
-            <a:avLst/>
-          </a:prstGeom>
-          <a:noFill/>
-          <a:ln/>
-        </p:spPr>
-        <p:txBody>
-          <a:bodyPr wrap="square" lIns="0" tIns="0" rIns="0" bIns="0" rtlCol="0" anchor="ctr"/>
-          <a:lstStyle/>
-          <a:p>
-            <a:pPr algn="ctr" indent="0" marL="0">
-              <a:buNone/>
-            </a:pPr>
-            <a:r>
-              <a:rPr lang="en-US" sz="1050" dirty="0">
-                <a:solidFill>
-                  <a:srgbClr val="7A7974"/>
-                </a:solidFill>
-                <a:latin typeface="Calibri" pitchFamily="34" charset="0"/>
-                <a:ea typeface="Calibri" pitchFamily="34" charset="-122"/>
-                <a:cs typeface="Calibri" pitchFamily="34" charset="-120"/>
-              </a:rPr>
-              <a:t>still ranked #1</a:t>
-            </a:r>
-            <a:endParaRPr lang="en-US" sz="1050" dirty="0"/>
-          </a:p>
-        </p:txBody>
-      </p:sp>
-      <p:sp>
-        <p:nvSpPr>
-          <p:cNvPr id="13" name="Shape 11"/>
-          <p:cNvSpPr/>
-          <p:nvPr/>
-        </p:nvSpPr>
-        <p:spPr>
-          <a:xfrm>
-            <a:off x="914400" y="3429000"/>
-            <a:ext cx="10332720" cy="1325880"/>
+      <p:pic>
+        <p:nvPicPr>
+          <p:cNvPr id="4" name="Image 0" descr="/tmp/Airport_PageRank/figures/damping-factor-sensitivity.png">    </p:cNvPr>
+          <p:cNvPicPr>
+            <a:picLocks noChangeAspect="1"/>
+          </p:cNvPicPr>
+          <p:nvPr/>
+        </p:nvPicPr>
+        <p:blipFill>
+          <a:blip r:embed="rId1"/>
+          <a:stretch>
+            <a:fillRect/>
+          </a:stretch>
+        </p:blipFill>
+        <p:spPr>
+          <a:xfrm>
+            <a:off x="548640" y="1188720"/>
+            <a:ext cx="6766560" cy="4059936"/>
+          </a:xfrm>
+          <a:prstGeom prst="rect">
+            <a:avLst/>
+          </a:prstGeom>
+        </p:spPr>
+      </p:pic>
+      <p:sp>
+        <p:nvSpPr>
+          <p:cNvPr id="5" name="Shape 2"/>
+          <p:cNvSpPr/>
+          <p:nvPr/>
+        </p:nvSpPr>
+        <p:spPr>
+          <a:xfrm>
+            <a:off x="7726680" y="1115568"/>
+            <a:ext cx="3931920" cy="4297680"/>
           </a:xfrm>
           <a:prstGeom prst="roundRect">
             <a:avLst>
-              <a:gd name="adj" fmla="val 5517"/>
+              <a:gd name="adj" fmla="val 1860"/>
             </a:avLst>
           </a:prstGeom>
           <a:solidFill>
-            <a:srgbClr val="E9F3F3"/>
+            <a:srgbClr val="FBFBF9"/>
           </a:solidFill>
           <a:ln w="12700">
             <a:solidFill>
@@ -7567,71 +8048,68 @@
       </p:sp>
       <p:sp>
         <p:nvSpPr>
-          <p:cNvPr id="14" name="Text 12"/>
-          <p:cNvSpPr/>
-          <p:nvPr/>
-        </p:nvSpPr>
-        <p:spPr>
-          <a:xfrm>
-            <a:off x="1234440" y="3703320"/>
-            <a:ext cx="1920240" cy="228600"/>
-          </a:xfrm>
-          <a:prstGeom prst="rect">
-            <a:avLst/>
-          </a:prstGeom>
-          <a:noFill/>
-          <a:ln/>
-        </p:spPr>
-        <p:txBody>
-          <a:bodyPr wrap="square" lIns="0" tIns="0" rIns="0" bIns="0" rtlCol="0" anchor="ctr"/>
-          <a:lstStyle/>
-          <a:p>
-            <a:pPr indent="0" marL="0">
-              <a:buNone/>
-            </a:pPr>
-            <a:r>
-              <a:rPr lang="en-US" sz="1500" b="1" dirty="0">
-                <a:solidFill>
-                  <a:srgbClr val="01696F"/>
+          <p:cNvPr id="6" name="Text 3"/>
+          <p:cNvSpPr/>
+          <p:nvPr/>
+        </p:nvSpPr>
+        <p:spPr>
+          <a:xfrm>
+            <a:off x="7909560" y="1417320"/>
+            <a:ext cx="3383280" cy="256032"/>
+          </a:xfrm>
+          <a:prstGeom prst="rect">
+            <a:avLst/>
+          </a:prstGeom>
+          <a:noFill/>
+          <a:ln/>
+        </p:spPr>
+        <p:txBody>
+          <a:bodyPr wrap="square" lIns="0" tIns="0" rIns="0" bIns="0" rtlCol="0" anchor="ctr"/>
+          <a:lstStyle/>
+          <a:p>
+            <a:pPr indent="0" marL="0">
+              <a:buNone/>
+            </a:pPr>
+            <a:r>
+              <a:rPr lang="en-US" sz="1600" b="1" dirty="0">
+                <a:solidFill>
+                  <a:srgbClr val="28251D"/>
                 </a:solidFill>
                 <a:latin typeface="Trebuchet MS" pitchFamily="34" charset="0"/>
                 <a:ea typeface="Trebuchet MS" pitchFamily="34" charset="-122"/>
                 <a:cs typeface="Trebuchet MS" pitchFamily="34" charset="-120"/>
               </a:rPr>
-              <a:t>Main finding</a:t>
-            </a:r>
-            <a:endParaRPr lang="en-US" sz="1500" dirty="0"/>
-          </a:p>
-        </p:txBody>
-      </p:sp>
-      <p:sp>
-        <p:nvSpPr>
-          <p:cNvPr id="15" name="Text 13"/>
-          <p:cNvSpPr/>
-          <p:nvPr/>
-        </p:nvSpPr>
-        <p:spPr>
-          <a:xfrm>
-            <a:off x="2880360" y="3675888"/>
-            <a:ext cx="7726680" cy="530352"/>
-          </a:xfrm>
-          <a:prstGeom prst="rect">
-            <a:avLst/>
-          </a:prstGeom>
-          <a:noFill/>
-          <a:ln/>
-        </p:spPr>
-        <p:txBody>
-          <a:bodyPr wrap="square" lIns="0" tIns="0" rIns="0" bIns="0" rtlCol="0" anchor="ctr">
+              <a:t>Setup</a:t>
+            </a:r>
+            <a:endParaRPr lang="en-US" sz="1600" dirty="0"/>
+          </a:p>
+        </p:txBody>
+      </p:sp>
+      <p:sp>
+        <p:nvSpPr>
+          <p:cNvPr id="7" name="Text 4"/>
+          <p:cNvSpPr/>
+          <p:nvPr/>
+        </p:nvSpPr>
+        <p:spPr>
+          <a:xfrm>
+            <a:off x="7909560" y="1755648"/>
+            <a:ext cx="3611880" cy="1280160"/>
+          </a:xfrm>
+          <a:prstGeom prst="rect">
+            <a:avLst/>
+          </a:prstGeom>
+          <a:noFill/>
+          <a:ln/>
+        </p:spPr>
+        <p:txBody>
+          <a:bodyPr wrap="square" lIns="635" tIns="635" rIns="635" bIns="635" rtlCol="0" anchor="ctr">
             <a:normAutofit/>
           </a:bodyPr>
           <a:lstStyle/>
           <a:p>
-            <a:pPr indent="0" marL="0">
-              <a:buNone/>
-            </a:pPr>
-            <a:r>
-              <a:rPr lang="en-US" sz="1600" dirty="0">
+            <a:r>
+              <a:rPr lang="en-US" sz="1260" dirty="0">
                 <a:solidFill>
                   <a:srgbClr val="28251D"/>
                 </a:solidFill>
@@ -7639,15 +8117,201 @@
                 <a:ea typeface="Calibri" pitchFamily="34" charset="-122"/>
                 <a:cs typeface="Calibri" pitchFamily="34" charset="-120"/>
               </a:rPr>
-              <a:t>The network does not collapse. Importance redistributes toward other major hubs, especially DEN, ORD, DFW, MSP, DTW, CLT, and IAH.</a:t>
-            </a:r>
-            <a:endParaRPr lang="en-US" sz="1600" dirty="0"/>
-          </a:p>
-        </p:txBody>
-      </p:sp>
-      <p:sp>
-        <p:nvSpPr>
-          <p:cNvPr id="16" name="Text 14"/>
+              <a:t>Recompute PageRank at d = 0.65, 0.75, 0.85, 0.95.</a:t>
+            </a:r>
+            <a:endParaRPr lang="en-US" sz="1260" dirty="0"/>
+          </a:p>
+          <a:p>
+            <a:r>
+              <a:rPr lang="en-US" sz="1260" dirty="0">
+                <a:solidFill>
+                  <a:srgbClr val="28251D"/>
+                </a:solidFill>
+                <a:latin typeface="Calibri" pitchFamily="34" charset="0"/>
+                <a:ea typeface="Calibri" pitchFamily="34" charset="-122"/>
+                <a:cs typeface="Calibri" pitchFamily="34" charset="-120"/>
+              </a:rPr>
+              <a:t>Same transition matrix, same tolerance.</a:t>
+            </a:r>
+            <a:endParaRPr lang="en-US" sz="1260" dirty="0"/>
+          </a:p>
+          <a:p>
+            <a:r>
+              <a:rPr lang="en-US" sz="1260" dirty="0">
+                <a:solidFill>
+                  <a:srgbClr val="28251D"/>
+                </a:solidFill>
+                <a:latin typeface="Calibri" pitchFamily="34" charset="0"/>
+                <a:ea typeface="Calibri" pitchFamily="34" charset="-122"/>
+                <a:cs typeface="Calibri" pitchFamily="34" charset="-120"/>
+              </a:rPr>
+              <a:t>Compare top hubs and full ranking.</a:t>
+            </a:r>
+            <a:endParaRPr lang="en-US" sz="1260" dirty="0"/>
+          </a:p>
+        </p:txBody>
+      </p:sp>
+      <p:sp>
+        <p:nvSpPr>
+          <p:cNvPr id="8" name="Text 5"/>
+          <p:cNvSpPr/>
+          <p:nvPr/>
+        </p:nvSpPr>
+        <p:spPr>
+          <a:xfrm>
+            <a:off x="7909560" y="3154680"/>
+            <a:ext cx="2286000" cy="237744"/>
+          </a:xfrm>
+          <a:prstGeom prst="rect">
+            <a:avLst/>
+          </a:prstGeom>
+          <a:noFill/>
+          <a:ln/>
+        </p:spPr>
+        <p:txBody>
+          <a:bodyPr wrap="square" lIns="0" tIns="0" rIns="0" bIns="0" rtlCol="0" anchor="ctr"/>
+          <a:lstStyle/>
+          <a:p>
+            <a:pPr indent="0" marL="0">
+              <a:buNone/>
+            </a:pPr>
+            <a:r>
+              <a:rPr lang="en-US" sz="1400" b="1" dirty="0">
+                <a:solidFill>
+                  <a:srgbClr val="01696F"/>
+                </a:solidFill>
+                <a:latin typeface="Trebuchet MS" pitchFamily="34" charset="0"/>
+                <a:ea typeface="Trebuchet MS" pitchFamily="34" charset="-122"/>
+                <a:cs typeface="Trebuchet MS" pitchFamily="34" charset="-120"/>
+              </a:rPr>
+              <a:t>Findings</a:t>
+            </a:r>
+            <a:endParaRPr lang="en-US" sz="1400" dirty="0"/>
+          </a:p>
+        </p:txBody>
+      </p:sp>
+      <p:sp>
+        <p:nvSpPr>
+          <p:cNvPr id="9" name="Text 6"/>
+          <p:cNvSpPr/>
+          <p:nvPr/>
+        </p:nvSpPr>
+        <p:spPr>
+          <a:xfrm>
+            <a:off x="7909560" y="3493008"/>
+            <a:ext cx="3611880" cy="1691640"/>
+          </a:xfrm>
+          <a:prstGeom prst="rect">
+            <a:avLst/>
+          </a:prstGeom>
+          <a:noFill/>
+          <a:ln/>
+        </p:spPr>
+        <p:txBody>
+          <a:bodyPr wrap="square" lIns="635" tIns="635" rIns="635" bIns="635" rtlCol="0" anchor="ctr">
+            <a:normAutofit/>
+          </a:bodyPr>
+          <a:lstStyle/>
+          <a:p>
+            <a:r>
+              <a:rPr lang="en-US" sz="1260" dirty="0">
+                <a:solidFill>
+                  <a:srgbClr val="28251D"/>
+                </a:solidFill>
+                <a:latin typeface="Calibri" pitchFamily="34" charset="0"/>
+                <a:ea typeface="Calibri" pitchFamily="34" charset="-122"/>
+                <a:cs typeface="Calibri" pitchFamily="34" charset="-120"/>
+              </a:rPr>
+              <a:t>DEN, ATL, ORD, DFW stay top 4 for every d.</a:t>
+            </a:r>
+            <a:endParaRPr lang="en-US" sz="1260" dirty="0"/>
+          </a:p>
+          <a:p>
+            <a:r>
+              <a:rPr lang="en-US" sz="1260" dirty="0">
+                <a:solidFill>
+                  <a:srgbClr val="28251D"/>
+                </a:solidFill>
+                <a:latin typeface="Calibri" pitchFamily="34" charset="0"/>
+                <a:ea typeface="Calibri" pitchFamily="34" charset="-122"/>
+                <a:cs typeface="Calibri" pitchFamily="34" charset="-120"/>
+              </a:rPr>
+              <a:t>Spearman ρ ≥ 0.988 vs baseline.</a:t>
+            </a:r>
+            <a:endParaRPr lang="en-US" sz="1260" dirty="0"/>
+          </a:p>
+          <a:p>
+            <a:r>
+              <a:rPr lang="en-US" sz="1260" dirty="0">
+                <a:solidFill>
+                  <a:srgbClr val="28251D"/>
+                </a:solidFill>
+                <a:latin typeface="Calibri" pitchFamily="34" charset="0"/>
+                <a:ea typeface="Calibri" pitchFamily="34" charset="-122"/>
+                <a:cs typeface="Calibri" pitchFamily="34" charset="-120"/>
+              </a:rPr>
+              <a:t>Top-10 set overlaps 9 of 10 in every case.</a:t>
+            </a:r>
+            <a:endParaRPr lang="en-US" sz="1260" dirty="0"/>
+          </a:p>
+          <a:p>
+            <a:r>
+              <a:rPr lang="en-US" sz="1260" dirty="0">
+                <a:solidFill>
+                  <a:srgbClr val="28251D"/>
+                </a:solidFill>
+                <a:latin typeface="Calibri" pitchFamily="34" charset="0"/>
+                <a:ea typeface="Calibri" pitchFamily="34" charset="-122"/>
+                <a:cs typeface="Calibri" pitchFamily="34" charset="-120"/>
+              </a:rPr>
+              <a:t>Iterations rise: 43 → 64 → 112 → 353.</a:t>
+            </a:r>
+            <a:endParaRPr lang="en-US" sz="1260" dirty="0"/>
+          </a:p>
+        </p:txBody>
+      </p:sp>
+      <p:sp>
+        <p:nvSpPr>
+          <p:cNvPr id="10" name="Text 7"/>
+          <p:cNvSpPr/>
+          <p:nvPr/>
+        </p:nvSpPr>
+        <p:spPr>
+          <a:xfrm>
+            <a:off x="685800" y="5532120"/>
+            <a:ext cx="10835640" cy="292608"/>
+          </a:xfrm>
+          <a:prstGeom prst="rect">
+            <a:avLst/>
+          </a:prstGeom>
+          <a:noFill/>
+          <a:ln/>
+        </p:spPr>
+        <p:txBody>
+          <a:bodyPr wrap="square" lIns="0" tIns="0" rIns="0" bIns="0" rtlCol="0" anchor="ctr"/>
+          <a:lstStyle/>
+          <a:p>
+            <a:pPr algn="ctr" indent="0" marL="0">
+              <a:buNone/>
+            </a:pPr>
+            <a:r>
+              <a:rPr lang="en-US" sz="1550" b="1" dirty="0">
+                <a:solidFill>
+                  <a:srgbClr val="01696F"/>
+                </a:solidFill>
+                <a:latin typeface="Calibri" pitchFamily="34" charset="0"/>
+                <a:ea typeface="Calibri" pitchFamily="34" charset="-122"/>
+                <a:cs typeface="Calibri" pitchFamily="34" charset="-120"/>
+              </a:rPr>
+              <a:t>Top hubs are driven by network structure, not by d = 0.85.</a:t>
+            </a:r>
+            <a:endParaRPr lang="en-US" sz="1550" dirty="0"/>
+          </a:p>
+        </p:txBody>
+      </p:sp>
+      <p:sp>
+        <p:nvSpPr>
+          <p:cNvPr id="11" name="Text 8"/>
           <p:cNvSpPr/>
           <p:nvPr/>
         </p:nvSpPr>
@@ -7679,41 +8343,6 @@
                 <a:cs typeface="Calibri" pitchFamily="34" charset="-120"/>
               </a:rPr>
               <a:t>Source: </a:t>
-            </a:r>
-            <a:pPr indent="0" marL="0">
-              <a:buNone/>
-            </a:pPr>
-            <a:r>
-              <a:rPr lang="en-US" sz="900" u="sng" dirty="0">
-                <a:solidFill>
-                  <a:srgbClr val="5A5952"/>
-                </a:solidFill>
-                <a:latin typeface="Calibri" pitchFamily="34" charset="0"/>
-                <a:ea typeface="Calibri" pitchFamily="34" charset="-122"/>
-                <a:cs typeface="Calibri" pitchFamily="34" charset="-120"/>
-                <a:hlinkClick r:id="rId1" invalidUrl="" action="" tgtFrame="" tooltip="" history="1" highlightClick="0" endSnd="0">
-                  <a:extLst>
-                    <a:ext uri="{A12FA001-AC4F-418D-AE19-62706E023703}">
-                      <ahyp:hlinkClr xmlns:ahyp="http://schemas.microsoft.com/office/drawing/2018/hyperlinkcolor" val="tx"/>
-                    </a:ext>
-                  </a:extLst>
-                </a:hlinkClick>
-              </a:rPr>
-              <a:t>OpenFlights</a:t>
-            </a:r>
-            <a:pPr indent="0" marL="0">
-              <a:buNone/>
-            </a:pPr>
-            <a:r>
-              <a:rPr lang="en-US" sz="900" dirty="0">
-                <a:solidFill>
-                  <a:srgbClr val="5A5952"/>
-                </a:solidFill>
-                <a:latin typeface="Calibri" pitchFamily="34" charset="0"/>
-                <a:ea typeface="Calibri" pitchFamily="34" charset="-122"/>
-                <a:cs typeface="Calibri" pitchFamily="34" charset="-120"/>
-              </a:rPr>
-              <a:t>; </a:t>
             </a:r>
             <a:pPr indent="0" marL="0">
               <a:buNone/>
@@ -7734,6 +8363,41 @@
                   </a:extLst>
                 </a:hlinkClick>
               </a:rPr>
+              <a:t>OpenFlights</a:t>
+            </a:r>
+            <a:pPr indent="0" marL="0">
+              <a:buNone/>
+            </a:pPr>
+            <a:r>
+              <a:rPr lang="en-US" sz="900" dirty="0">
+                <a:solidFill>
+                  <a:srgbClr val="5A5952"/>
+                </a:solidFill>
+                <a:latin typeface="Calibri" pitchFamily="34" charset="0"/>
+                <a:ea typeface="Calibri" pitchFamily="34" charset="-122"/>
+                <a:cs typeface="Calibri" pitchFamily="34" charset="-120"/>
+              </a:rPr>
+              <a:t>; </a:t>
+            </a:r>
+            <a:pPr indent="0" marL="0">
+              <a:buNone/>
+            </a:pPr>
+            <a:r>
+              <a:rPr lang="en-US" sz="900" u="sng" dirty="0">
+                <a:solidFill>
+                  <a:srgbClr val="5A5952"/>
+                </a:solidFill>
+                <a:latin typeface="Calibri" pitchFamily="34" charset="0"/>
+                <a:ea typeface="Calibri" pitchFamily="34" charset="-122"/>
+                <a:cs typeface="Calibri" pitchFamily="34" charset="-120"/>
+                <a:hlinkClick r:id="rId3" invalidUrl="" action="" tgtFrame="" tooltip="" history="1" highlightClick="0" endSnd="0">
+                  <a:extLst>
+                    <a:ext uri="{A12FA001-AC4F-418D-AE19-62706E023703}">
+                      <ahyp:hlinkClr xmlns:ahyp="http://schemas.microsoft.com/office/drawing/2018/hyperlinkcolor" val="tx"/>
+                    </a:ext>
+                  </a:extLst>
+                </a:hlinkClick>
+              </a:rPr>
               <a:t>project notebook</a:t>
             </a:r>
             <a:endParaRPr lang="en-US" sz="900" dirty="0"/>
@@ -7742,7 +8406,7 @@
       </p:sp>
       <p:sp>
         <p:nvSpPr>
-          <p:cNvPr id="17" name="Text 15"/>
+          <p:cNvPr id="12" name="Text 9"/>
           <p:cNvSpPr/>
           <p:nvPr/>
         </p:nvSpPr>
@@ -7844,7 +8508,7 @@
                 <a:ea typeface="Trebuchet MS" pitchFamily="34" charset="-122"/>
                 <a:cs typeface="Trebuchet MS" pitchFamily="34" charset="-120"/>
               </a:rPr>
-              <a:t>Rank Changes After Removing ATL</a:t>
+              <a:t>Hub Closure Experiment</a:t>
             </a:r>
             <a:endParaRPr lang="en-US" sz="2400" dirty="0"/>
           </a:p>
@@ -7883,54 +8547,381 @@
                 <a:ea typeface="Calibri" pitchFamily="34" charset="-122"/>
                 <a:cs typeface="Calibri" pitchFamily="34" charset="-120"/>
               </a:rPr>
-              <a:t>Largest movements in the disrupted network</a:t>
+              <a:t>What happens when ATL is removed?</a:t>
             </a:r>
             <a:endParaRPr lang="en-US" sz="1050" dirty="0"/>
           </a:p>
         </p:txBody>
       </p:sp>
-      <p:pic>
-        <p:nvPicPr>
-          <p:cNvPr id="4" name="Image 0" descr="/home/user/workspace/Airport_PageRank/figures/atl-removal-rank-changes-slide.png">    </p:cNvPr>
-          <p:cNvPicPr>
-            <a:picLocks noChangeAspect="1"/>
-          </p:cNvPicPr>
-          <p:nvPr/>
-        </p:nvPicPr>
-        <p:blipFill>
-          <a:blip r:embed="rId1"/>
-          <a:stretch>
-            <a:fillRect/>
-          </a:stretch>
-        </p:blipFill>
-        <p:spPr>
-          <a:xfrm>
-            <a:off x="685800" y="1234440"/>
-            <a:ext cx="6629400" cy="3758184"/>
-          </a:xfrm>
-          <a:prstGeom prst="rect">
-            <a:avLst/>
-          </a:prstGeom>
-        </p:spPr>
-      </p:pic>
-      <p:sp>
-        <p:nvSpPr>
-          <p:cNvPr id="5" name="Shape 2"/>
-          <p:cNvSpPr/>
-          <p:nvPr/>
-        </p:nvSpPr>
-        <p:spPr>
-          <a:xfrm>
-            <a:off x="7680960" y="1143000"/>
-            <a:ext cx="3611880" cy="4023360"/>
+      <p:sp>
+        <p:nvSpPr>
+          <p:cNvPr id="4" name="Text 2"/>
+          <p:cNvSpPr/>
+          <p:nvPr/>
+        </p:nvSpPr>
+        <p:spPr>
+          <a:xfrm>
+            <a:off x="685800" y="1207008"/>
+            <a:ext cx="9784080" cy="347472"/>
+          </a:xfrm>
+          <a:prstGeom prst="rect">
+            <a:avLst/>
+          </a:prstGeom>
+          <a:noFill/>
+          <a:ln/>
+        </p:spPr>
+        <p:txBody>
+          <a:bodyPr wrap="square" lIns="0" tIns="0" rIns="0" bIns="0" rtlCol="0" anchor="ctr"/>
+          <a:lstStyle/>
+          <a:p>
+            <a:pPr indent="0" marL="0">
+              <a:buNone/>
+            </a:pPr>
+            <a:r>
+              <a:rPr lang="en-US" sz="1500" dirty="0">
+                <a:solidFill>
+                  <a:srgbClr val="28251D"/>
+                </a:solidFill>
+                <a:latin typeface="Calibri" pitchFamily="34" charset="0"/>
+                <a:ea typeface="Calibri" pitchFamily="34" charset="-122"/>
+                <a:cs typeface="Calibri" pitchFamily="34" charset="-120"/>
+              </a:rPr>
+              <a:t>Simulation: remove all incoming and outgoing ATL routes, rebuild the matrices, and recompute PageRank.</a:t>
+            </a:r>
+            <a:endParaRPr lang="en-US" sz="1500" dirty="0"/>
+          </a:p>
+        </p:txBody>
+      </p:sp>
+      <p:sp>
+        <p:nvSpPr>
+          <p:cNvPr id="5" name="Text 3"/>
+          <p:cNvSpPr/>
+          <p:nvPr/>
+        </p:nvSpPr>
+        <p:spPr>
+          <a:xfrm>
+            <a:off x="868680" y="1874520"/>
+            <a:ext cx="1920240" cy="566928"/>
+          </a:xfrm>
+          <a:prstGeom prst="rect">
+            <a:avLst/>
+          </a:prstGeom>
+          <a:noFill/>
+          <a:ln/>
+        </p:spPr>
+        <p:txBody>
+          <a:bodyPr wrap="square" lIns="0" tIns="0" rIns="0" bIns="0" rtlCol="0" anchor="ctr"/>
+          <a:lstStyle/>
+          <a:p>
+            <a:pPr algn="ctr" indent="0" marL="0">
+              <a:buNone/>
+            </a:pPr>
+            <a:r>
+              <a:rPr lang="en-US" sz="3000" b="1" dirty="0">
+                <a:solidFill>
+                  <a:srgbClr val="A13544"/>
+                </a:solidFill>
+                <a:latin typeface="Trebuchet MS" pitchFamily="34" charset="0"/>
+                <a:ea typeface="Trebuchet MS" pitchFamily="34" charset="-122"/>
+                <a:cs typeface="Trebuchet MS" pitchFamily="34" charset="-120"/>
+              </a:rPr>
+              <a:t>ATL</a:t>
+            </a:r>
+            <a:endParaRPr lang="en-US" sz="3000" dirty="0"/>
+          </a:p>
+        </p:txBody>
+      </p:sp>
+      <p:sp>
+        <p:nvSpPr>
+          <p:cNvPr id="6" name="Text 4"/>
+          <p:cNvSpPr/>
+          <p:nvPr/>
+        </p:nvSpPr>
+        <p:spPr>
+          <a:xfrm>
+            <a:off x="868680" y="2478024"/>
+            <a:ext cx="1920240" cy="274320"/>
+          </a:xfrm>
+          <a:prstGeom prst="rect">
+            <a:avLst/>
+          </a:prstGeom>
+          <a:noFill/>
+          <a:ln/>
+        </p:spPr>
+        <p:txBody>
+          <a:bodyPr wrap="square" lIns="0" tIns="0" rIns="0" bIns="0" rtlCol="0" anchor="ctr"/>
+          <a:lstStyle/>
+          <a:p>
+            <a:pPr algn="ctr" indent="0" marL="0">
+              <a:buNone/>
+            </a:pPr>
+            <a:r>
+              <a:rPr lang="en-US" sz="1050" dirty="0">
+                <a:solidFill>
+                  <a:srgbClr val="7A7974"/>
+                </a:solidFill>
+                <a:latin typeface="Calibri" pitchFamily="34" charset="0"/>
+                <a:ea typeface="Calibri" pitchFamily="34" charset="-122"/>
+                <a:cs typeface="Calibri" pitchFamily="34" charset="-120"/>
+              </a:rPr>
+              <a:t>removed hub</a:t>
+            </a:r>
+            <a:endParaRPr lang="en-US" sz="1050" dirty="0"/>
+          </a:p>
+        </p:txBody>
+      </p:sp>
+      <p:sp>
+        <p:nvSpPr>
+          <p:cNvPr id="7" name="Text 5"/>
+          <p:cNvSpPr/>
+          <p:nvPr/>
+        </p:nvSpPr>
+        <p:spPr>
+          <a:xfrm>
+            <a:off x="3063240" y="1874520"/>
+            <a:ext cx="2240280" cy="566928"/>
+          </a:xfrm>
+          <a:prstGeom prst="rect">
+            <a:avLst/>
+          </a:prstGeom>
+          <a:noFill/>
+          <a:ln/>
+        </p:spPr>
+        <p:txBody>
+          <a:bodyPr wrap="square" lIns="0" tIns="0" rIns="0" bIns="0" rtlCol="0" anchor="ctr"/>
+          <a:lstStyle/>
+          <a:p>
+            <a:pPr algn="ctr" indent="0" marL="0">
+              <a:buNone/>
+            </a:pPr>
+            <a:r>
+              <a:rPr lang="en-US" sz="3000" b="1" dirty="0">
+                <a:solidFill>
+                  <a:srgbClr val="01696F"/>
+                </a:solidFill>
+                <a:latin typeface="Trebuchet MS" pitchFamily="34" charset="0"/>
+                <a:ea typeface="Trebuchet MS" pitchFamily="34" charset="-122"/>
+                <a:cs typeface="Trebuchet MS" pitchFamily="34" charset="-120"/>
+              </a:rPr>
+              <a:t>5,145</a:t>
+            </a:r>
+            <a:endParaRPr lang="en-US" sz="3000" dirty="0"/>
+          </a:p>
+        </p:txBody>
+      </p:sp>
+      <p:sp>
+        <p:nvSpPr>
+          <p:cNvPr id="8" name="Text 6"/>
+          <p:cNvSpPr/>
+          <p:nvPr/>
+        </p:nvSpPr>
+        <p:spPr>
+          <a:xfrm>
+            <a:off x="3063240" y="2478024"/>
+            <a:ext cx="2240280" cy="274320"/>
+          </a:xfrm>
+          <a:prstGeom prst="rect">
+            <a:avLst/>
+          </a:prstGeom>
+          <a:noFill/>
+          <a:ln/>
+        </p:spPr>
+        <p:txBody>
+          <a:bodyPr wrap="square" lIns="0" tIns="0" rIns="0" bIns="0" rtlCol="0" anchor="ctr"/>
+          <a:lstStyle/>
+          <a:p>
+            <a:pPr algn="ctr" indent="0" marL="0">
+              <a:buNone/>
+            </a:pPr>
+            <a:r>
+              <a:rPr lang="en-US" sz="1050" dirty="0">
+                <a:solidFill>
+                  <a:srgbClr val="7A7974"/>
+                </a:solidFill>
+                <a:latin typeface="Calibri" pitchFamily="34" charset="0"/>
+                <a:ea typeface="Calibri" pitchFamily="34" charset="-122"/>
+                <a:cs typeface="Calibri" pitchFamily="34" charset="-120"/>
+              </a:rPr>
+              <a:t>remaining directed routes</a:t>
+            </a:r>
+            <a:endParaRPr lang="en-US" sz="1050" dirty="0"/>
+          </a:p>
+        </p:txBody>
+      </p:sp>
+      <p:sp>
+        <p:nvSpPr>
+          <p:cNvPr id="9" name="Text 7"/>
+          <p:cNvSpPr/>
+          <p:nvPr/>
+        </p:nvSpPr>
+        <p:spPr>
+          <a:xfrm>
+            <a:off x="5559552" y="1874520"/>
+            <a:ext cx="2057400" cy="566928"/>
+          </a:xfrm>
+          <a:prstGeom prst="rect">
+            <a:avLst/>
+          </a:prstGeom>
+          <a:noFill/>
+          <a:ln/>
+        </p:spPr>
+        <p:txBody>
+          <a:bodyPr wrap="square" lIns="0" tIns="0" rIns="0" bIns="0" rtlCol="0" anchor="ctr"/>
+          <a:lstStyle/>
+          <a:p>
+            <a:pPr algn="ctr" indent="0" marL="0">
+              <a:buNone/>
+            </a:pPr>
+            <a:r>
+              <a:rPr lang="en-US" sz="3000" b="1" dirty="0">
+                <a:solidFill>
+                  <a:srgbClr val="01696F"/>
+                </a:solidFill>
+                <a:latin typeface="Trebuchet MS" pitchFamily="34" charset="0"/>
+                <a:ea typeface="Trebuchet MS" pitchFamily="34" charset="-122"/>
+                <a:cs typeface="Trebuchet MS" pitchFamily="34" charset="-120"/>
+              </a:rPr>
+              <a:t>112</a:t>
+            </a:r>
+            <a:endParaRPr lang="en-US" sz="3000" dirty="0"/>
+          </a:p>
+        </p:txBody>
+      </p:sp>
+      <p:sp>
+        <p:nvSpPr>
+          <p:cNvPr id="10" name="Text 8"/>
+          <p:cNvSpPr/>
+          <p:nvPr/>
+        </p:nvSpPr>
+        <p:spPr>
+          <a:xfrm>
+            <a:off x="5559552" y="2478024"/>
+            <a:ext cx="2057400" cy="274320"/>
+          </a:xfrm>
+          <a:prstGeom prst="rect">
+            <a:avLst/>
+          </a:prstGeom>
+          <a:noFill/>
+          <a:ln/>
+        </p:spPr>
+        <p:txBody>
+          <a:bodyPr wrap="square" lIns="0" tIns="0" rIns="0" bIns="0" rtlCol="0" anchor="ctr"/>
+          <a:lstStyle/>
+          <a:p>
+            <a:pPr algn="ctr" indent="0" marL="0">
+              <a:buNone/>
+            </a:pPr>
+            <a:r>
+              <a:rPr lang="en-US" sz="1050" dirty="0">
+                <a:solidFill>
+                  <a:srgbClr val="7A7974"/>
+                </a:solidFill>
+                <a:latin typeface="Calibri" pitchFamily="34" charset="0"/>
+                <a:ea typeface="Calibri" pitchFamily="34" charset="-122"/>
+                <a:cs typeface="Calibri" pitchFamily="34" charset="-120"/>
+              </a:rPr>
+              <a:t>post-closure iterations</a:t>
+            </a:r>
+            <a:endParaRPr lang="en-US" sz="1050" dirty="0"/>
+          </a:p>
+        </p:txBody>
+      </p:sp>
+      <p:sp>
+        <p:nvSpPr>
+          <p:cNvPr id="11" name="Text 9"/>
+          <p:cNvSpPr/>
+          <p:nvPr/>
+        </p:nvSpPr>
+        <p:spPr>
+          <a:xfrm>
+            <a:off x="7909560" y="1874520"/>
+            <a:ext cx="1920240" cy="566928"/>
+          </a:xfrm>
+          <a:prstGeom prst="rect">
+            <a:avLst/>
+          </a:prstGeom>
+          <a:noFill/>
+          <a:ln/>
+        </p:spPr>
+        <p:txBody>
+          <a:bodyPr wrap="square" lIns="0" tIns="0" rIns="0" bIns="0" rtlCol="0" anchor="ctr"/>
+          <a:lstStyle/>
+          <a:p>
+            <a:pPr algn="ctr" indent="0" marL="0">
+              <a:buNone/>
+            </a:pPr>
+            <a:r>
+              <a:rPr lang="en-US" sz="3000" b="1" dirty="0">
+                <a:solidFill>
+                  <a:srgbClr val="01696F"/>
+                </a:solidFill>
+                <a:latin typeface="Trebuchet MS" pitchFamily="34" charset="0"/>
+                <a:ea typeface="Trebuchet MS" pitchFamily="34" charset="-122"/>
+                <a:cs typeface="Trebuchet MS" pitchFamily="34" charset="-120"/>
+              </a:rPr>
+              <a:t>DEN</a:t>
+            </a:r>
+            <a:endParaRPr lang="en-US" sz="3000" dirty="0"/>
+          </a:p>
+        </p:txBody>
+      </p:sp>
+      <p:sp>
+        <p:nvSpPr>
+          <p:cNvPr id="12" name="Text 10"/>
+          <p:cNvSpPr/>
+          <p:nvPr/>
+        </p:nvSpPr>
+        <p:spPr>
+          <a:xfrm>
+            <a:off x="7909560" y="2478024"/>
+            <a:ext cx="1920240" cy="274320"/>
+          </a:xfrm>
+          <a:prstGeom prst="rect">
+            <a:avLst/>
+          </a:prstGeom>
+          <a:noFill/>
+          <a:ln/>
+        </p:spPr>
+        <p:txBody>
+          <a:bodyPr wrap="square" lIns="0" tIns="0" rIns="0" bIns="0" rtlCol="0" anchor="ctr"/>
+          <a:lstStyle/>
+          <a:p>
+            <a:pPr algn="ctr" indent="0" marL="0">
+              <a:buNone/>
+            </a:pPr>
+            <a:r>
+              <a:rPr lang="en-US" sz="1050" dirty="0">
+                <a:solidFill>
+                  <a:srgbClr val="7A7974"/>
+                </a:solidFill>
+                <a:latin typeface="Calibri" pitchFamily="34" charset="0"/>
+                <a:ea typeface="Calibri" pitchFamily="34" charset="-122"/>
+                <a:cs typeface="Calibri" pitchFamily="34" charset="-120"/>
+              </a:rPr>
+              <a:t>still ranked #1</a:t>
+            </a:r>
+            <a:endParaRPr lang="en-US" sz="1050" dirty="0"/>
+          </a:p>
+        </p:txBody>
+      </p:sp>
+      <p:sp>
+        <p:nvSpPr>
+          <p:cNvPr id="13" name="Shape 11"/>
+          <p:cNvSpPr/>
+          <p:nvPr/>
+        </p:nvSpPr>
+        <p:spPr>
+          <a:xfrm>
+            <a:off x="914400" y="3429000"/>
+            <a:ext cx="10332720" cy="1325880"/>
           </a:xfrm>
           <a:prstGeom prst="roundRect">
             <a:avLst>
-              <a:gd name="adj" fmla="val 2025"/>
+              <a:gd name="adj" fmla="val 5517"/>
             </a:avLst>
           </a:prstGeom>
           <a:solidFill>
-            <a:srgbClr val="FBFBF9"/>
+            <a:srgbClr val="E9F3F3"/>
           </a:solidFill>
           <a:ln w="12700">
             <a:solidFill>
@@ -7942,158 +8933,53 @@
       </p:sp>
       <p:sp>
         <p:nvSpPr>
-          <p:cNvPr id="6" name="Text 3"/>
-          <p:cNvSpPr/>
-          <p:nvPr/>
-        </p:nvSpPr>
-        <p:spPr>
-          <a:xfrm>
-            <a:off x="8001000" y="1508760"/>
-            <a:ext cx="2651760" cy="256032"/>
-          </a:xfrm>
-          <a:prstGeom prst="rect">
-            <a:avLst/>
-          </a:prstGeom>
-          <a:noFill/>
-          <a:ln/>
-        </p:spPr>
-        <p:txBody>
-          <a:bodyPr wrap="square" lIns="0" tIns="0" rIns="0" bIns="0" rtlCol="0" anchor="ctr"/>
-          <a:lstStyle/>
-          <a:p>
-            <a:pPr indent="0" marL="0">
-              <a:buNone/>
-            </a:pPr>
-            <a:r>
-              <a:rPr lang="en-US" sz="1600" b="1" dirty="0">
-                <a:solidFill>
-                  <a:srgbClr val="28251D"/>
+          <p:cNvPr id="14" name="Text 12"/>
+          <p:cNvSpPr/>
+          <p:nvPr/>
+        </p:nvSpPr>
+        <p:spPr>
+          <a:xfrm>
+            <a:off x="1234440" y="3703320"/>
+            <a:ext cx="1920240" cy="228600"/>
+          </a:xfrm>
+          <a:prstGeom prst="rect">
+            <a:avLst/>
+          </a:prstGeom>
+          <a:noFill/>
+          <a:ln/>
+        </p:spPr>
+        <p:txBody>
+          <a:bodyPr wrap="square" lIns="0" tIns="0" rIns="0" bIns="0" rtlCol="0" anchor="ctr"/>
+          <a:lstStyle/>
+          <a:p>
+            <a:pPr indent="0" marL="0">
+              <a:buNone/>
+            </a:pPr>
+            <a:r>
+              <a:rPr lang="en-US" sz="1500" b="1" dirty="0">
+                <a:solidFill>
+                  <a:srgbClr val="01696F"/>
                 </a:solidFill>
                 <a:latin typeface="Trebuchet MS" pitchFamily="34" charset="0"/>
                 <a:ea typeface="Trebuchet MS" pitchFamily="34" charset="-122"/>
                 <a:cs typeface="Trebuchet MS" pitchFamily="34" charset="-120"/>
               </a:rPr>
-              <a:t>How to read this</a:t>
-            </a:r>
-            <a:endParaRPr lang="en-US" sz="1600" dirty="0"/>
-          </a:p>
-        </p:txBody>
-      </p:sp>
-      <p:sp>
-        <p:nvSpPr>
-          <p:cNvPr id="7" name="Text 4"/>
-          <p:cNvSpPr/>
-          <p:nvPr/>
-        </p:nvSpPr>
-        <p:spPr>
-          <a:xfrm>
-            <a:off x="8001000" y="1920240"/>
-            <a:ext cx="2834640" cy="1600200"/>
-          </a:xfrm>
-          <a:prstGeom prst="rect">
-            <a:avLst/>
-          </a:prstGeom>
-          <a:noFill/>
-          <a:ln/>
-        </p:spPr>
-        <p:txBody>
-          <a:bodyPr wrap="square" lIns="635" tIns="635" rIns="635" bIns="635" rtlCol="0" anchor="ctr">
-            <a:normAutofit/>
-          </a:bodyPr>
-          <a:lstStyle/>
-          <a:p>
-            <a:r>
-              <a:rPr lang="en-US" sz="1260" dirty="0">
-                <a:solidFill>
-                  <a:srgbClr val="28251D"/>
-                </a:solidFill>
-                <a:latin typeface="Calibri" pitchFamily="34" charset="0"/>
-                <a:ea typeface="Calibri" pitchFamily="34" charset="-122"/>
-                <a:cs typeface="Calibri" pitchFamily="34" charset="-120"/>
-              </a:rPr>
-              <a:t>Positive rank change means the airport moved up.</a:t>
-            </a:r>
-            <a:endParaRPr lang="en-US" sz="1260" dirty="0"/>
-          </a:p>
-          <a:p>
-            <a:r>
-              <a:rPr lang="en-US" sz="1260" dirty="0">
-                <a:solidFill>
-                  <a:srgbClr val="28251D"/>
-                </a:solidFill>
-                <a:latin typeface="Calibri" pitchFamily="34" charset="0"/>
-                <a:ea typeface="Calibri" pitchFamily="34" charset="-122"/>
-                <a:cs typeface="Calibri" pitchFamily="34" charset="-120"/>
-              </a:rPr>
-              <a:t>Negative rank change means it moved down.</a:t>
-            </a:r>
-            <a:endParaRPr lang="en-US" sz="1260" dirty="0"/>
-          </a:p>
-          <a:p>
-            <a:r>
-              <a:rPr lang="en-US" sz="1260" dirty="0">
-                <a:solidFill>
-                  <a:srgbClr val="28251D"/>
-                </a:solidFill>
-                <a:latin typeface="Calibri" pitchFamily="34" charset="0"/>
-                <a:ea typeface="Calibri" pitchFamily="34" charset="-122"/>
-                <a:cs typeface="Calibri" pitchFamily="34" charset="-120"/>
-              </a:rPr>
-              <a:t>Small airports can jump many ranks because bottom scores are very close.</a:t>
-            </a:r>
-            <a:endParaRPr lang="en-US" sz="1260" dirty="0"/>
-          </a:p>
-        </p:txBody>
-      </p:sp>
-      <p:sp>
-        <p:nvSpPr>
-          <p:cNvPr id="8" name="Text 5"/>
-          <p:cNvSpPr/>
-          <p:nvPr/>
-        </p:nvSpPr>
-        <p:spPr>
-          <a:xfrm>
-            <a:off x="8001000" y="3977640"/>
-            <a:ext cx="1828800" cy="219456"/>
-          </a:xfrm>
-          <a:prstGeom prst="rect">
-            <a:avLst/>
-          </a:prstGeom>
-          <a:noFill/>
-          <a:ln/>
-        </p:spPr>
-        <p:txBody>
-          <a:bodyPr wrap="square" lIns="0" tIns="0" rIns="0" bIns="0" rtlCol="0" anchor="ctr"/>
-          <a:lstStyle/>
-          <a:p>
-            <a:pPr indent="0" marL="0">
-              <a:buNone/>
-            </a:pPr>
-            <a:r>
-              <a:rPr lang="en-US" sz="1350" b="1" dirty="0">
-                <a:solidFill>
-                  <a:srgbClr val="01696F"/>
-                </a:solidFill>
-                <a:latin typeface="Trebuchet MS" pitchFamily="34" charset="0"/>
-                <a:ea typeface="Trebuchet MS" pitchFamily="34" charset="-122"/>
-                <a:cs typeface="Trebuchet MS" pitchFamily="34" charset="-120"/>
-              </a:rPr>
-              <a:t>Key message</a:t>
-            </a:r>
-            <a:endParaRPr lang="en-US" sz="1350" dirty="0"/>
-          </a:p>
-        </p:txBody>
-      </p:sp>
-      <p:sp>
-        <p:nvSpPr>
-          <p:cNvPr id="9" name="Text 6"/>
-          <p:cNvSpPr/>
-          <p:nvPr/>
-        </p:nvSpPr>
-        <p:spPr>
-          <a:xfrm>
-            <a:off x="8001000" y="4279392"/>
-            <a:ext cx="2880360" cy="411480"/>
+              <a:t>Main finding</a:t>
+            </a:r>
+            <a:endParaRPr lang="en-US" sz="1500" dirty="0"/>
+          </a:p>
+        </p:txBody>
+      </p:sp>
+      <p:sp>
+        <p:nvSpPr>
+          <p:cNvPr id="15" name="Text 13"/>
+          <p:cNvSpPr/>
+          <p:nvPr/>
+        </p:nvSpPr>
+        <p:spPr>
+          <a:xfrm>
+            <a:off x="2880360" y="3675888"/>
+            <a:ext cx="7726680" cy="530352"/>
           </a:xfrm>
           <a:prstGeom prst="rect">
             <a:avLst/>
@@ -8111,7 +8997,7 @@
               <a:buNone/>
             </a:pPr>
             <a:r>
-              <a:rPr lang="en-US" sz="1200" dirty="0">
+              <a:rPr lang="en-US" sz="1600" dirty="0">
                 <a:solidFill>
                   <a:srgbClr val="28251D"/>
                 </a:solidFill>
@@ -8119,15 +9005,15 @@
                 <a:ea typeface="Calibri" pitchFamily="34" charset="-122"/>
                 <a:cs typeface="Calibri" pitchFamily="34" charset="-120"/>
               </a:rPr>
-              <a:t>For hub-level interpretation, PageRank score change matters more than rank alone.</a:t>
-            </a:r>
-            <a:endParaRPr lang="en-US" sz="1200" dirty="0"/>
-          </a:p>
-        </p:txBody>
-      </p:sp>
-      <p:sp>
-        <p:nvSpPr>
-          <p:cNvPr id="10" name="Text 7"/>
+              <a:t>The network does not collapse. Importance redistributes toward other major hubs, especially DEN, ORD, DFW, MSP, DTW, CLT, and IAH.</a:t>
+            </a:r>
+            <a:endParaRPr lang="en-US" sz="1600" dirty="0"/>
+          </a:p>
+        </p:txBody>
+      </p:sp>
+      <p:sp>
+        <p:nvSpPr>
+          <p:cNvPr id="16" name="Text 14"/>
           <p:cNvSpPr/>
           <p:nvPr/>
         </p:nvSpPr>
@@ -8159,6 +9045,41 @@
                 <a:cs typeface="Calibri" pitchFamily="34" charset="-120"/>
               </a:rPr>
               <a:t>Source: </a:t>
+            </a:r>
+            <a:pPr indent="0" marL="0">
+              <a:buNone/>
+            </a:pPr>
+            <a:r>
+              <a:rPr lang="en-US" sz="900" u="sng" dirty="0">
+                <a:solidFill>
+                  <a:srgbClr val="5A5952"/>
+                </a:solidFill>
+                <a:latin typeface="Calibri" pitchFamily="34" charset="0"/>
+                <a:ea typeface="Calibri" pitchFamily="34" charset="-122"/>
+                <a:cs typeface="Calibri" pitchFamily="34" charset="-120"/>
+                <a:hlinkClick r:id="rId1" invalidUrl="" action="" tgtFrame="" tooltip="" history="1" highlightClick="0" endSnd="0">
+                  <a:extLst>
+                    <a:ext uri="{A12FA001-AC4F-418D-AE19-62706E023703}">
+                      <ahyp:hlinkClr xmlns:ahyp="http://schemas.microsoft.com/office/drawing/2018/hyperlinkcolor" val="tx"/>
+                    </a:ext>
+                  </a:extLst>
+                </a:hlinkClick>
+              </a:rPr>
+              <a:t>OpenFlights</a:t>
+            </a:r>
+            <a:pPr indent="0" marL="0">
+              <a:buNone/>
+            </a:pPr>
+            <a:r>
+              <a:rPr lang="en-US" sz="900" dirty="0">
+                <a:solidFill>
+                  <a:srgbClr val="5A5952"/>
+                </a:solidFill>
+                <a:latin typeface="Calibri" pitchFamily="34" charset="0"/>
+                <a:ea typeface="Calibri" pitchFamily="34" charset="-122"/>
+                <a:cs typeface="Calibri" pitchFamily="34" charset="-120"/>
+              </a:rPr>
+              <a:t>; </a:t>
             </a:r>
             <a:pPr indent="0" marL="0">
               <a:buNone/>
@@ -8179,41 +9100,6 @@
                   </a:extLst>
                 </a:hlinkClick>
               </a:rPr>
-              <a:t>OpenFlights</a:t>
-            </a:r>
-            <a:pPr indent="0" marL="0">
-              <a:buNone/>
-            </a:pPr>
-            <a:r>
-              <a:rPr lang="en-US" sz="900" dirty="0">
-                <a:solidFill>
-                  <a:srgbClr val="5A5952"/>
-                </a:solidFill>
-                <a:latin typeface="Calibri" pitchFamily="34" charset="0"/>
-                <a:ea typeface="Calibri" pitchFamily="34" charset="-122"/>
-                <a:cs typeface="Calibri" pitchFamily="34" charset="-120"/>
-              </a:rPr>
-              <a:t>; </a:t>
-            </a:r>
-            <a:pPr indent="0" marL="0">
-              <a:buNone/>
-            </a:pPr>
-            <a:r>
-              <a:rPr lang="en-US" sz="900" u="sng" dirty="0">
-                <a:solidFill>
-                  <a:srgbClr val="5A5952"/>
-                </a:solidFill>
-                <a:latin typeface="Calibri" pitchFamily="34" charset="0"/>
-                <a:ea typeface="Calibri" pitchFamily="34" charset="-122"/>
-                <a:cs typeface="Calibri" pitchFamily="34" charset="-120"/>
-                <a:hlinkClick r:id="rId3" invalidUrl="" action="" tgtFrame="" tooltip="" history="1" highlightClick="0" endSnd="0">
-                  <a:extLst>
-                    <a:ext uri="{A12FA001-AC4F-418D-AE19-62706E023703}">
-                      <ahyp:hlinkClr xmlns:ahyp="http://schemas.microsoft.com/office/drawing/2018/hyperlinkcolor" val="tx"/>
-                    </a:ext>
-                  </a:extLst>
-                </a:hlinkClick>
-              </a:rPr>
               <a:t>project notebook</a:t>
             </a:r>
             <a:endParaRPr lang="en-US" sz="900" dirty="0"/>
@@ -8222,7 +9108,7 @@
       </p:sp>
       <p:sp>
         <p:nvSpPr>
-          <p:cNvPr id="11" name="Text 8"/>
+          <p:cNvPr id="17" name="Text 15"/>
           <p:cNvSpPr/>
           <p:nvPr/>
         </p:nvSpPr>
@@ -8324,7 +9210,7 @@
                 <a:ea typeface="Trebuchet MS" pitchFamily="34" charset="-122"/>
                 <a:cs typeface="Trebuchet MS" pitchFamily="34" charset="-120"/>
               </a:rPr>
-              <a:t>What We Learned</a:t>
+              <a:t>Rank Changes After Removing ATL</a:t>
             </a:r>
             <a:endParaRPr lang="en-US" sz="2400" dirty="0"/>
           </a:p>
@@ -8363,135 +9249,50 @@
                 <a:ea typeface="Calibri" pitchFamily="34" charset="-122"/>
                 <a:cs typeface="Calibri" pitchFamily="34" charset="-120"/>
               </a:rPr>
-              <a:t>Centrality and resilience in one model</a:t>
+              <a:t>Largest movements in the disrupted network</a:t>
             </a:r>
             <a:endParaRPr lang="en-US" sz="1050" dirty="0"/>
           </a:p>
         </p:txBody>
       </p:sp>
-      <p:sp>
-        <p:nvSpPr>
-          <p:cNvPr id="4" name="Shape 2"/>
-          <p:cNvSpPr/>
-          <p:nvPr/>
-        </p:nvSpPr>
-        <p:spPr>
-          <a:xfrm>
-            <a:off x="685800" y="1325880"/>
-            <a:ext cx="3429000" cy="2377440"/>
+      <p:pic>
+        <p:nvPicPr>
+          <p:cNvPr id="4" name="Image 0" descr="/tmp/Airport_PageRank/figures/atl-removal-rank-changes-slide.png">    </p:cNvPr>
+          <p:cNvPicPr>
+            <a:picLocks noChangeAspect="1"/>
+          </p:cNvPicPr>
+          <p:nvPr/>
+        </p:nvPicPr>
+        <p:blipFill>
+          <a:blip r:embed="rId1"/>
+          <a:stretch>
+            <a:fillRect/>
+          </a:stretch>
+        </p:blipFill>
+        <p:spPr>
+          <a:xfrm>
+            <a:off x="685800" y="1234440"/>
+            <a:ext cx="6629400" cy="3758184"/>
+          </a:xfrm>
+          <a:prstGeom prst="rect">
+            <a:avLst/>
+          </a:prstGeom>
+        </p:spPr>
+      </p:pic>
+      <p:sp>
+        <p:nvSpPr>
+          <p:cNvPr id="5" name="Shape 2"/>
+          <p:cNvSpPr/>
+          <p:nvPr/>
+        </p:nvSpPr>
+        <p:spPr>
+          <a:xfrm>
+            <a:off x="7680960" y="1143000"/>
+            <a:ext cx="3611880" cy="4023360"/>
           </a:xfrm>
           <a:prstGeom prst="roundRect">
             <a:avLst>
-              <a:gd name="adj" fmla="val 3077"/>
-            </a:avLst>
-          </a:prstGeom>
-          <a:solidFill>
-            <a:srgbClr val="E9F3F3"/>
-          </a:solidFill>
-          <a:ln w="12700">
-            <a:solidFill>
-              <a:srgbClr val="D4D1CA">
-                <a:alpha val="90000"/>
-              </a:srgbClr>
-            </a:solidFill>
-            <a:prstDash val="solid"/>
-          </a:ln>
-        </p:spPr>
-      </p:sp>
-      <p:sp>
-        <p:nvSpPr>
-          <p:cNvPr id="5" name="Text 3"/>
-          <p:cNvSpPr/>
-          <p:nvPr/>
-        </p:nvSpPr>
-        <p:spPr>
-          <a:xfrm>
-            <a:off x="886968" y="1490472"/>
-            <a:ext cx="3026664" cy="228600"/>
-          </a:xfrm>
-          <a:prstGeom prst="rect">
-            <a:avLst/>
-          </a:prstGeom>
-          <a:noFill/>
-          <a:ln/>
-        </p:spPr>
-        <p:txBody>
-          <a:bodyPr wrap="square" lIns="0" tIns="0" rIns="0" bIns="0" rtlCol="0" anchor="ctr"/>
-          <a:lstStyle/>
-          <a:p>
-            <a:pPr indent="0" marL="0">
-              <a:buNone/>
-            </a:pPr>
-            <a:r>
-              <a:rPr lang="en-US" sz="1400" b="1" dirty="0">
-                <a:solidFill>
-                  <a:srgbClr val="01696F"/>
-                </a:solidFill>
-                <a:latin typeface="Trebuchet MS" pitchFamily="34" charset="0"/>
-                <a:ea typeface="Trebuchet MS" pitchFamily="34" charset="-122"/>
-                <a:cs typeface="Trebuchet MS" pitchFamily="34" charset="-120"/>
-              </a:rPr>
-              <a:t>1. Centrality is recursive</a:t>
-            </a:r>
-            <a:endParaRPr lang="en-US" sz="1400" dirty="0"/>
-          </a:p>
-        </p:txBody>
-      </p:sp>
-      <p:sp>
-        <p:nvSpPr>
-          <p:cNvPr id="6" name="Text 4"/>
-          <p:cNvSpPr/>
-          <p:nvPr/>
-        </p:nvSpPr>
-        <p:spPr>
-          <a:xfrm>
-            <a:off x="886968" y="1828800"/>
-            <a:ext cx="3026664" cy="1691640"/>
-          </a:xfrm>
-          <a:prstGeom prst="rect">
-            <a:avLst/>
-          </a:prstGeom>
-          <a:noFill/>
-          <a:ln/>
-        </p:spPr>
-        <p:txBody>
-          <a:bodyPr wrap="square" lIns="254" tIns="254" rIns="254" bIns="254" rtlCol="0" anchor="t">
-            <a:normAutofit/>
-          </a:bodyPr>
-          <a:lstStyle/>
-          <a:p>
-            <a:pPr indent="0" marL="0">
-              <a:buNone/>
-            </a:pPr>
-            <a:r>
-              <a:rPr lang="en-US" sz="1250" dirty="0">
-                <a:solidFill>
-                  <a:srgbClr val="28251D"/>
-                </a:solidFill>
-                <a:latin typeface="Calibri" pitchFamily="34" charset="0"/>
-                <a:ea typeface="Calibri" pitchFamily="34" charset="-122"/>
-                <a:cs typeface="Calibri" pitchFamily="34" charset="-120"/>
-              </a:rPr>
-              <a:t>An airport is important when it is connected to other important airports, not only when it has many direct routes.</a:t>
-            </a:r>
-            <a:endParaRPr lang="en-US" sz="1250" dirty="0"/>
-          </a:p>
-        </p:txBody>
-      </p:sp>
-      <p:sp>
-        <p:nvSpPr>
-          <p:cNvPr id="7" name="Shape 5"/>
-          <p:cNvSpPr/>
-          <p:nvPr/>
-        </p:nvSpPr>
-        <p:spPr>
-          <a:xfrm>
-            <a:off x="4389120" y="1325880"/>
-            <a:ext cx="3429000" cy="2377440"/>
-          </a:xfrm>
-          <a:prstGeom prst="roundRect">
-            <a:avLst>
-              <a:gd name="adj" fmla="val 3077"/>
+              <a:gd name="adj" fmla="val 2025"/>
             </a:avLst>
           </a:prstGeom>
           <a:solidFill>
@@ -8499,9 +9300,7 @@
           </a:solidFill>
           <a:ln w="12700">
             <a:solidFill>
-              <a:srgbClr val="D4D1CA">
-                <a:alpha val="90000"/>
-              </a:srgbClr>
+              <a:srgbClr val="D4D1CA"/>
             </a:solidFill>
             <a:prstDash val="solid"/>
           </a:ln>
@@ -8509,30 +9308,30 @@
       </p:sp>
       <p:sp>
         <p:nvSpPr>
-          <p:cNvPr id="8" name="Text 6"/>
-          <p:cNvSpPr/>
-          <p:nvPr/>
-        </p:nvSpPr>
-        <p:spPr>
-          <a:xfrm>
-            <a:off x="4590288" y="1490472"/>
-            <a:ext cx="3026664" cy="228600"/>
-          </a:xfrm>
-          <a:prstGeom prst="rect">
-            <a:avLst/>
-          </a:prstGeom>
-          <a:noFill/>
-          <a:ln/>
-        </p:spPr>
-        <p:txBody>
-          <a:bodyPr wrap="square" lIns="0" tIns="0" rIns="0" bIns="0" rtlCol="0" anchor="ctr"/>
-          <a:lstStyle/>
-          <a:p>
-            <a:pPr indent="0" marL="0">
-              <a:buNone/>
-            </a:pPr>
-            <a:r>
-              <a:rPr lang="en-US" sz="1400" b="1" dirty="0">
+          <p:cNvPr id="6" name="Text 3"/>
+          <p:cNvSpPr/>
+          <p:nvPr/>
+        </p:nvSpPr>
+        <p:spPr>
+          <a:xfrm>
+            <a:off x="8001000" y="1508760"/>
+            <a:ext cx="2651760" cy="256032"/>
+          </a:xfrm>
+          <a:prstGeom prst="rect">
+            <a:avLst/>
+          </a:prstGeom>
+          <a:noFill/>
+          <a:ln/>
+        </p:spPr>
+        <p:txBody>
+          <a:bodyPr wrap="square" lIns="0" tIns="0" rIns="0" bIns="0" rtlCol="0" anchor="ctr"/>
+          <a:lstStyle/>
+          <a:p>
+            <a:pPr indent="0" marL="0">
+              <a:buNone/>
+            </a:pPr>
+            <a:r>
+              <a:rPr lang="en-US" sz="1600" b="1" dirty="0">
                 <a:solidFill>
                   <a:srgbClr val="28251D"/>
                 </a:solidFill>
@@ -8540,40 +9339,37 @@
                 <a:ea typeface="Trebuchet MS" pitchFamily="34" charset="-122"/>
                 <a:cs typeface="Trebuchet MS" pitchFamily="34" charset="-120"/>
               </a:rPr>
-              <a:t>2. The network is resilient</a:t>
-            </a:r>
-            <a:endParaRPr lang="en-US" sz="1400" dirty="0"/>
-          </a:p>
-        </p:txBody>
-      </p:sp>
-      <p:sp>
-        <p:nvSpPr>
-          <p:cNvPr id="9" name="Text 7"/>
-          <p:cNvSpPr/>
-          <p:nvPr/>
-        </p:nvSpPr>
-        <p:spPr>
-          <a:xfrm>
-            <a:off x="4590288" y="1828800"/>
-            <a:ext cx="3026664" cy="1691640"/>
-          </a:xfrm>
-          <a:prstGeom prst="rect">
-            <a:avLst/>
-          </a:prstGeom>
-          <a:noFill/>
-          <a:ln/>
-        </p:spPr>
-        <p:txBody>
-          <a:bodyPr wrap="square" lIns="254" tIns="254" rIns="254" bIns="254" rtlCol="0" anchor="t">
+              <a:t>How to read this</a:t>
+            </a:r>
+            <a:endParaRPr lang="en-US" sz="1600" dirty="0"/>
+          </a:p>
+        </p:txBody>
+      </p:sp>
+      <p:sp>
+        <p:nvSpPr>
+          <p:cNvPr id="7" name="Text 4"/>
+          <p:cNvSpPr/>
+          <p:nvPr/>
+        </p:nvSpPr>
+        <p:spPr>
+          <a:xfrm>
+            <a:off x="8001000" y="1920240"/>
+            <a:ext cx="2834640" cy="1600200"/>
+          </a:xfrm>
+          <a:prstGeom prst="rect">
+            <a:avLst/>
+          </a:prstGeom>
+          <a:noFill/>
+          <a:ln/>
+        </p:spPr>
+        <p:txBody>
+          <a:bodyPr wrap="square" lIns="635" tIns="635" rIns="635" bIns="635" rtlCol="0" anchor="ctr">
             <a:normAutofit/>
           </a:bodyPr>
           <a:lstStyle/>
           <a:p>
-            <a:pPr indent="0" marL="0">
-              <a:buNone/>
-            </a:pPr>
-            <a:r>
-              <a:rPr lang="en-US" sz="1250" dirty="0">
+            <a:r>
+              <a:rPr lang="en-US" sz="1260" dirty="0">
                 <a:solidFill>
                   <a:srgbClr val="28251D"/>
                 </a:solidFill>
@@ -8581,99 +9377,98 @@
                 <a:ea typeface="Calibri" pitchFamily="34" charset="-122"/>
                 <a:cs typeface="Calibri" pitchFamily="34" charset="-120"/>
               </a:rPr>
-              <a:t>Removing ATL changes rankings, but other hubs absorb importance. The national structure remains connected through multiple hubs.</a:t>
-            </a:r>
-            <a:endParaRPr lang="en-US" sz="1250" dirty="0"/>
-          </a:p>
-        </p:txBody>
-      </p:sp>
-      <p:sp>
-        <p:nvSpPr>
-          <p:cNvPr id="10" name="Shape 8"/>
-          <p:cNvSpPr/>
-          <p:nvPr/>
-        </p:nvSpPr>
-        <p:spPr>
-          <a:xfrm>
-            <a:off x="8092440" y="1325880"/>
-            <a:ext cx="3429000" cy="2377440"/>
-          </a:xfrm>
-          <a:prstGeom prst="roundRect">
-            <a:avLst>
-              <a:gd name="adj" fmla="val 3077"/>
-            </a:avLst>
-          </a:prstGeom>
-          <a:solidFill>
-            <a:srgbClr val="FBFBF9"/>
-          </a:solidFill>
-          <a:ln w="12700">
-            <a:solidFill>
-              <a:srgbClr val="D4D1CA">
-                <a:alpha val="90000"/>
-              </a:srgbClr>
-            </a:solidFill>
-            <a:prstDash val="solid"/>
-          </a:ln>
-        </p:spPr>
-      </p:sp>
-      <p:sp>
-        <p:nvSpPr>
-          <p:cNvPr id="11" name="Text 9"/>
-          <p:cNvSpPr/>
-          <p:nvPr/>
-        </p:nvSpPr>
-        <p:spPr>
-          <a:xfrm>
-            <a:off x="8293608" y="1490472"/>
-            <a:ext cx="3026664" cy="228600"/>
-          </a:xfrm>
-          <a:prstGeom prst="rect">
-            <a:avLst/>
-          </a:prstGeom>
-          <a:noFill/>
-          <a:ln/>
-        </p:spPr>
-        <p:txBody>
-          <a:bodyPr wrap="square" lIns="0" tIns="0" rIns="0" bIns="0" rtlCol="0" anchor="ctr"/>
-          <a:lstStyle/>
-          <a:p>
-            <a:pPr indent="0" marL="0">
-              <a:buNone/>
-            </a:pPr>
-            <a:r>
-              <a:rPr lang="en-US" sz="1400" b="1" dirty="0">
+              <a:t>Positive rank change means the airport moved up.</a:t>
+            </a:r>
+            <a:endParaRPr lang="en-US" sz="1260" dirty="0"/>
+          </a:p>
+          <a:p>
+            <a:r>
+              <a:rPr lang="en-US" sz="1260" dirty="0">
                 <a:solidFill>
                   <a:srgbClr val="28251D"/>
+                </a:solidFill>
+                <a:latin typeface="Calibri" pitchFamily="34" charset="0"/>
+                <a:ea typeface="Calibri" pitchFamily="34" charset="-122"/>
+                <a:cs typeface="Calibri" pitchFamily="34" charset="-120"/>
+              </a:rPr>
+              <a:t>Negative rank change means it moved down.</a:t>
+            </a:r>
+            <a:endParaRPr lang="en-US" sz="1260" dirty="0"/>
+          </a:p>
+          <a:p>
+            <a:r>
+              <a:rPr lang="en-US" sz="1260" dirty="0">
+                <a:solidFill>
+                  <a:srgbClr val="28251D"/>
+                </a:solidFill>
+                <a:latin typeface="Calibri" pitchFamily="34" charset="0"/>
+                <a:ea typeface="Calibri" pitchFamily="34" charset="-122"/>
+                <a:cs typeface="Calibri" pitchFamily="34" charset="-120"/>
+              </a:rPr>
+              <a:t>Small airports can jump many ranks because bottom scores are very close.</a:t>
+            </a:r>
+            <a:endParaRPr lang="en-US" sz="1260" dirty="0"/>
+          </a:p>
+        </p:txBody>
+      </p:sp>
+      <p:sp>
+        <p:nvSpPr>
+          <p:cNvPr id="8" name="Text 5"/>
+          <p:cNvSpPr/>
+          <p:nvPr/>
+        </p:nvSpPr>
+        <p:spPr>
+          <a:xfrm>
+            <a:off x="8001000" y="3977640"/>
+            <a:ext cx="1828800" cy="219456"/>
+          </a:xfrm>
+          <a:prstGeom prst="rect">
+            <a:avLst/>
+          </a:prstGeom>
+          <a:noFill/>
+          <a:ln/>
+        </p:spPr>
+        <p:txBody>
+          <a:bodyPr wrap="square" lIns="0" tIns="0" rIns="0" bIns="0" rtlCol="0" anchor="ctr"/>
+          <a:lstStyle/>
+          <a:p>
+            <a:pPr indent="0" marL="0">
+              <a:buNone/>
+            </a:pPr>
+            <a:r>
+              <a:rPr lang="en-US" sz="1350" b="1" dirty="0">
+                <a:solidFill>
+                  <a:srgbClr val="01696F"/>
                 </a:solidFill>
                 <a:latin typeface="Trebuchet MS" pitchFamily="34" charset="0"/>
                 <a:ea typeface="Trebuchet MS" pitchFamily="34" charset="-122"/>
                 <a:cs typeface="Trebuchet MS" pitchFamily="34" charset="-120"/>
               </a:rPr>
-              <a:t>3. Local vulnerability remains</a:t>
-            </a:r>
-            <a:endParaRPr lang="en-US" sz="1400" dirty="0"/>
-          </a:p>
-        </p:txBody>
-      </p:sp>
-      <p:sp>
-        <p:nvSpPr>
-          <p:cNvPr id="12" name="Text 10"/>
-          <p:cNvSpPr/>
-          <p:nvPr/>
-        </p:nvSpPr>
-        <p:spPr>
-          <a:xfrm>
-            <a:off x="8293608" y="1828800"/>
-            <a:ext cx="3026664" cy="1691640"/>
-          </a:xfrm>
-          <a:prstGeom prst="rect">
-            <a:avLst/>
-          </a:prstGeom>
-          <a:noFill/>
-          <a:ln/>
-        </p:spPr>
-        <p:txBody>
-          <a:bodyPr wrap="square" lIns="254" tIns="254" rIns="254" bIns="254" rtlCol="0" anchor="t">
+              <a:t>Key message</a:t>
+            </a:r>
+            <a:endParaRPr lang="en-US" sz="1350" dirty="0"/>
+          </a:p>
+        </p:txBody>
+      </p:sp>
+      <p:sp>
+        <p:nvSpPr>
+          <p:cNvPr id="9" name="Text 6"/>
+          <p:cNvSpPr/>
+          <p:nvPr/>
+        </p:nvSpPr>
+        <p:spPr>
+          <a:xfrm>
+            <a:off x="8001000" y="4279392"/>
+            <a:ext cx="2880360" cy="411480"/>
+          </a:xfrm>
+          <a:prstGeom prst="rect">
+            <a:avLst/>
+          </a:prstGeom>
+          <a:noFill/>
+          <a:ln/>
+        </p:spPr>
+        <p:txBody>
+          <a:bodyPr wrap="square" lIns="0" tIns="0" rIns="0" bIns="0" rtlCol="0" anchor="ctr">
             <a:normAutofit/>
           </a:bodyPr>
           <a:lstStyle/>
@@ -8682,7 +9477,7 @@
               <a:buNone/>
             </a:pPr>
             <a:r>
-              <a:rPr lang="en-US" sz="1250" dirty="0">
+              <a:rPr lang="en-US" sz="1200" dirty="0">
                 <a:solidFill>
                   <a:srgbClr val="28251D"/>
                 </a:solidFill>
@@ -8690,54 +9485,15 @@
                 <a:ea typeface="Calibri" pitchFamily="34" charset="-122"/>
                 <a:cs typeface="Calibri" pitchFamily="34" charset="-120"/>
               </a:rPr>
-              <a:t>Some regional airports lose importance when ATL is removed, showing that local dependence can be high even if the full network is resilient.</a:t>
-            </a:r>
-            <a:endParaRPr lang="en-US" sz="1250" dirty="0"/>
-          </a:p>
-        </p:txBody>
-      </p:sp>
-      <p:sp>
-        <p:nvSpPr>
-          <p:cNvPr id="13" name="Text 11"/>
-          <p:cNvSpPr/>
-          <p:nvPr/>
-        </p:nvSpPr>
-        <p:spPr>
-          <a:xfrm>
-            <a:off x="914400" y="4800600"/>
-            <a:ext cx="10332720" cy="384048"/>
-          </a:xfrm>
-          <a:prstGeom prst="rect">
-            <a:avLst/>
-          </a:prstGeom>
-          <a:noFill/>
-          <a:ln/>
-        </p:spPr>
-        <p:txBody>
-          <a:bodyPr wrap="square" lIns="0" tIns="0" rIns="0" bIns="0" rtlCol="0" anchor="ctr"/>
-          <a:lstStyle/>
-          <a:p>
-            <a:pPr algn="ctr" indent="0" marL="0">
-              <a:buNone/>
-            </a:pPr>
-            <a:r>
-              <a:rPr lang="en-US" sz="1800" b="1" dirty="0">
-                <a:solidFill>
-                  <a:srgbClr val="01696F"/>
-                </a:solidFill>
-                <a:latin typeface="Calibri" pitchFamily="34" charset="0"/>
-                <a:ea typeface="Calibri" pitchFamily="34" charset="-122"/>
-                <a:cs typeface="Calibri" pitchFamily="34" charset="-120"/>
-              </a:rPr>
-              <a:t>PageRank gives a linear algebra-based way to quantify both structural importance and disruption response.</a:t>
-            </a:r>
-            <a:endParaRPr lang="en-US" sz="1800" dirty="0"/>
-          </a:p>
-        </p:txBody>
-      </p:sp>
-      <p:sp>
-        <p:nvSpPr>
-          <p:cNvPr id="14" name="Text 12"/>
+              <a:t>For hub-level interpretation, PageRank score change matters more than rank alone.</a:t>
+            </a:r>
+            <a:endParaRPr lang="en-US" sz="1200" dirty="0"/>
+          </a:p>
+        </p:txBody>
+      </p:sp>
+      <p:sp>
+        <p:nvSpPr>
+          <p:cNvPr id="10" name="Text 7"/>
           <p:cNvSpPr/>
           <p:nvPr/>
         </p:nvSpPr>
@@ -8769,41 +9525,6 @@
                 <a:cs typeface="Calibri" pitchFamily="34" charset="-120"/>
               </a:rPr>
               <a:t>Source: </a:t>
-            </a:r>
-            <a:pPr indent="0" marL="0">
-              <a:buNone/>
-            </a:pPr>
-            <a:r>
-              <a:rPr lang="en-US" sz="900" u="sng" dirty="0">
-                <a:solidFill>
-                  <a:srgbClr val="5A5952"/>
-                </a:solidFill>
-                <a:latin typeface="Calibri" pitchFamily="34" charset="0"/>
-                <a:ea typeface="Calibri" pitchFamily="34" charset="-122"/>
-                <a:cs typeface="Calibri" pitchFamily="34" charset="-120"/>
-                <a:hlinkClick r:id="rId1" invalidUrl="" action="" tgtFrame="" tooltip="" history="1" highlightClick="0" endSnd="0">
-                  <a:extLst>
-                    <a:ext uri="{A12FA001-AC4F-418D-AE19-62706E023703}">
-                      <ahyp:hlinkClr xmlns:ahyp="http://schemas.microsoft.com/office/drawing/2018/hyperlinkcolor" val="tx"/>
-                    </a:ext>
-                  </a:extLst>
-                </a:hlinkClick>
-              </a:rPr>
-              <a:t>OpenFlights</a:t>
-            </a:r>
-            <a:pPr indent="0" marL="0">
-              <a:buNone/>
-            </a:pPr>
-            <a:r>
-              <a:rPr lang="en-US" sz="900" dirty="0">
-                <a:solidFill>
-                  <a:srgbClr val="5A5952"/>
-                </a:solidFill>
-                <a:latin typeface="Calibri" pitchFamily="34" charset="0"/>
-                <a:ea typeface="Calibri" pitchFamily="34" charset="-122"/>
-                <a:cs typeface="Calibri" pitchFamily="34" charset="-120"/>
-              </a:rPr>
-              <a:t>; </a:t>
             </a:r>
             <a:pPr indent="0" marL="0">
               <a:buNone/>
@@ -8824,6 +9545,41 @@
                   </a:extLst>
                 </a:hlinkClick>
               </a:rPr>
+              <a:t>OpenFlights</a:t>
+            </a:r>
+            <a:pPr indent="0" marL="0">
+              <a:buNone/>
+            </a:pPr>
+            <a:r>
+              <a:rPr lang="en-US" sz="900" dirty="0">
+                <a:solidFill>
+                  <a:srgbClr val="5A5952"/>
+                </a:solidFill>
+                <a:latin typeface="Calibri" pitchFamily="34" charset="0"/>
+                <a:ea typeface="Calibri" pitchFamily="34" charset="-122"/>
+                <a:cs typeface="Calibri" pitchFamily="34" charset="-120"/>
+              </a:rPr>
+              <a:t>; </a:t>
+            </a:r>
+            <a:pPr indent="0" marL="0">
+              <a:buNone/>
+            </a:pPr>
+            <a:r>
+              <a:rPr lang="en-US" sz="900" u="sng" dirty="0">
+                <a:solidFill>
+                  <a:srgbClr val="5A5952"/>
+                </a:solidFill>
+                <a:latin typeface="Calibri" pitchFamily="34" charset="0"/>
+                <a:ea typeface="Calibri" pitchFamily="34" charset="-122"/>
+                <a:cs typeface="Calibri" pitchFamily="34" charset="-120"/>
+                <a:hlinkClick r:id="rId3" invalidUrl="" action="" tgtFrame="" tooltip="" history="1" highlightClick="0" endSnd="0">
+                  <a:extLst>
+                    <a:ext uri="{A12FA001-AC4F-418D-AE19-62706E023703}">
+                      <ahyp:hlinkClr xmlns:ahyp="http://schemas.microsoft.com/office/drawing/2018/hyperlinkcolor" val="tx"/>
+                    </a:ext>
+                  </a:extLst>
+                </a:hlinkClick>
+              </a:rPr>
               <a:t>project notebook</a:t>
             </a:r>
             <a:endParaRPr lang="en-US" sz="900" dirty="0"/>
@@ -8832,7 +9588,7 @@
       </p:sp>
       <p:sp>
         <p:nvSpPr>
-          <p:cNvPr id="15" name="Text 13"/>
+          <p:cNvPr id="11" name="Text 8"/>
           <p:cNvSpPr/>
           <p:nvPr/>
         </p:nvSpPr>

</xml_diff>